<commit_message>
fix(hardening): finalize 18-slide presentation, Stan/rstanarm R models, target distinction, and submission status
</commit_message>
<xml_diff>
--- a/reports/final/FINAL_PRESENTATION.pptx
+++ b/reports/final/FINAL_PRESENTATION.pptx
@@ -23,7 +23,6 @@
     <p:sldId id="271" r:id="rId22"/>
     <p:sldId id="272" r:id="rId23"/>
     <p:sldId id="273" r:id="rId24"/>
-    <p:sldId id="274" r:id="rId25"/>
   </p:sldIdLst>
   <p:sldSz cx="12191695" cy="6858000" type="screen4x3"/>
   <p:notesSz cx="6858000" cy="9144000"/>
@@ -3145,7 +3144,7 @@
               </a:defRPr>
             </a:pPr>
             <a:r>
-              <a:t>Bayesian Regime Detection Engine for Equity Direction Forecasting</a:t>
+              <a:t>1. Bayesian Regime Detection Engine: Problem &amp; Objective</a:t>
             </a:r>
           </a:p>
           <a:p>
@@ -3172,7 +3171,7 @@
         <p:spPr>
           <a:xfrm>
             <a:off x="731520" y="1828800"/>
-            <a:ext cx="10698480" cy="4114800"/>
+            <a:ext cx="10698480" cy="4206240"/>
           </a:xfrm>
           <a:prstGeom prst="rect">
             <a:avLst/>
@@ -3193,59 +3192,59 @@
                 <a:solidFill>
                   <a:srgbClr val="2C3E50"/>
                 </a:solidFill>
-                <a:latin typeface="Calibri"/>
-              </a:defRPr>
-            </a:pPr>
-            <a:r>
-              <a:t>•  Organization: Zetheta Algorithms Private Limited (CIN: U62012MH2023PTC410415)</a:t>
-            </a:r>
-          </a:p>
-          <a:p>
-            <a:pPr>
-              <a:spcAft>
-                <a:spcPts val="1400"/>
-              </a:spcAft>
-              <a:defRPr sz="1400">
-                <a:solidFill>
-                  <a:srgbClr val="2C3E50"/>
-                </a:solidFill>
-                <a:latin typeface="Calibri"/>
-              </a:defRPr>
-            </a:pPr>
-            <a:r>
-              <a:t>•  Target Environment: Python 3.10 | Host Runtime: macOS ARM64 / Linux x86_64</a:t>
-            </a:r>
-          </a:p>
-          <a:p>
-            <a:pPr>
-              <a:spcAft>
-                <a:spcPts val="1400"/>
-              </a:spcAft>
-              <a:defRPr sz="1400">
-                <a:solidFill>
-                  <a:srgbClr val="2C3E50"/>
-                </a:solidFill>
-                <a:latin typeface="Calibri"/>
-              </a:defRPr>
-            </a:pPr>
-            <a:r>
-              <a:t>•  Release Version: v1.0.0-institutional | Verification Suite: 70/70 Tests Passing</a:t>
-            </a:r>
-          </a:p>
-          <a:p>
-            <a:pPr>
-              <a:spcAft>
-                <a:spcPts val="1400"/>
-              </a:spcAft>
-              <a:defRPr sz="1400">
-                <a:solidFill>
-                  <a:srgbClr val="2C3E50"/>
-                </a:solidFill>
-                <a:latin typeface="Calibri"/>
-              </a:defRPr>
-            </a:pPr>
-            <a:r>
-              <a:t>•  Executive Objective: Non-stationary macro regime detection &amp; conviction-scaled asset allocation</a:t>
+                <a:latin typeface="Arial"/>
+              </a:defRPr>
+            </a:pPr>
+            <a:r>
+              <a:t>•  Organization: Zetheta Algorithms Private Limited (CIN: U62012MH2023PTC410415).</a:t>
+            </a:r>
+          </a:p>
+          <a:p>
+            <a:pPr>
+              <a:spcAft>
+                <a:spcPts val="1400"/>
+              </a:spcAft>
+              <a:defRPr sz="1400">
+                <a:solidFill>
+                  <a:srgbClr val="2C3E50"/>
+                </a:solidFill>
+                <a:latin typeface="Arial"/>
+              </a:defRPr>
+            </a:pPr>
+            <a:r>
+              <a:t>•  Target Canonical Environment: Python 3.10 | Host Platform: macOS ARM64 / Linux x86_64.</a:t>
+            </a:r>
+          </a:p>
+          <a:p>
+            <a:pPr>
+              <a:spcAft>
+                <a:spcPts val="1400"/>
+              </a:spcAft>
+              <a:defRPr sz="1400">
+                <a:solidFill>
+                  <a:srgbClr val="2C3E50"/>
+                </a:solidFill>
+                <a:latin typeface="Arial"/>
+              </a:defRPr>
+            </a:pPr>
+            <a:r>
+              <a:t>•  The Problem: Financial price series have signal-to-noise ratio &lt; 0.05; point forecasting fails out-of-sample.</a:t>
+            </a:r>
+          </a:p>
+          <a:p>
+            <a:pPr>
+              <a:spcAft>
+                <a:spcPts val="1400"/>
+              </a:spcAft>
+              <a:defRPr sz="1400">
+                <a:solidFill>
+                  <a:srgbClr val="2C3E50"/>
+                </a:solidFill>
+                <a:latin typeface="Arial"/>
+              </a:defRPr>
+            </a:pPr>
+            <a:r>
+              <a:t>•  The Objective: Predict probability distributions over 5 macroeconomic regimes for tactical equity allocation.</a:t>
             </a:r>
           </a:p>
         </p:txBody>
@@ -3277,7 +3276,7 @@
                 <a:solidFill>
                   <a:srgbClr val="7F8C8D"/>
                 </a:solidFill>
-                <a:latin typeface="Calibri"/>
+                <a:latin typeface="Arial"/>
               </a:defRPr>
             </a:pPr>
             <a:r>
@@ -3343,7 +3342,7 @@
               </a:defRPr>
             </a:pPr>
             <a:r>
-              <a:t>9. Information Criteria: WAIC &amp; PSIS-LOO Diagnostics</a:t>
+              <a:t>10. Simplex Stacking Ensemble &amp; Benchmark Tournament</a:t>
             </a:r>
           </a:p>
           <a:p>
@@ -3356,7 +3355,7 @@
               </a:defRPr>
             </a:pPr>
             <a:r>
-              <a:t>Formal Out-of-Sample Density Assessment via ArviZ</a:t>
+              <a:t>Out-of-Sample Holdout (2022–2024, 738 Days) Proper-Score Audit</a:t>
             </a:r>
           </a:p>
         </p:txBody>
@@ -3370,7 +3369,7 @@
         <p:spPr>
           <a:xfrm>
             <a:off x="731520" y="1828800"/>
-            <a:ext cx="10698480" cy="4114800"/>
+            <a:ext cx="10698480" cy="4206240"/>
           </a:xfrm>
           <a:prstGeom prst="rect">
             <a:avLst/>
@@ -3391,59 +3390,59 @@
                 <a:solidFill>
                   <a:srgbClr val="2C3E50"/>
                 </a:solidFill>
-                <a:latin typeface="Calibri"/>
-              </a:defRPr>
-            </a:pPr>
-            <a:r>
-              <a:t>•  Watanabe-Akaike Information Criterion (WAIC): Computed from MCMC pointwise log-likelihood draws.</a:t>
-            </a:r>
-          </a:p>
-          <a:p>
-            <a:pPr>
-              <a:spcAft>
-                <a:spcPts val="1400"/>
-              </a:spcAft>
-              <a:defRPr sz="1400">
-                <a:solidFill>
-                  <a:srgbClr val="2C3E50"/>
-                </a:solidFill>
-                <a:latin typeface="Calibri"/>
-              </a:defRPr>
-            </a:pPr>
-            <a:r>
-              <a:t>•  PSIS-LOO Cross-Validation: Pareto-smoothed importance sampling LOO (elpd_loo = -28,412.4, SE = 142.1).</a:t>
-            </a:r>
-          </a:p>
-          <a:p>
-            <a:pPr>
-              <a:spcAft>
-                <a:spcPts val="1400"/>
-              </a:spcAft>
-              <a:defRPr sz="1400">
-                <a:solidFill>
-                  <a:srgbClr val="2C3E50"/>
-                </a:solidFill>
-                <a:latin typeface="Calibri"/>
-              </a:defRPr>
-            </a:pPr>
-            <a:r>
-              <a:t>•  Pareto-k Diagnostic: 98.2% of observations have k &lt;= 0.5; 0.0% exceed 0.7, confirming stable posteriors.</a:t>
-            </a:r>
-          </a:p>
-          <a:p>
-            <a:pPr>
-              <a:spcAft>
-                <a:spcPts val="1400"/>
-              </a:spcAft>
-              <a:defRPr sz="1400">
-                <a:solidFill>
-                  <a:srgbClr val="2C3E50"/>
-                </a:solidFill>
-                <a:latin typeface="Calibri"/>
-              </a:defRPr>
-            </a:pPr>
-            <a:r>
-              <a:t>•  Mathematical Rigor: Zero reliance on naive AIC/BIC asymptotic approximations for Bayesian models.</a:t>
+                <a:latin typeface="Arial"/>
+              </a:defRPr>
+            </a:pPr>
+            <a:r>
+              <a:t>•  Simplex Stacking: SLSQP optimization on Delta^M assigns 90.9% to Deep Ensemble and 9.1% to Bayesian HMM (Gibbs).</a:t>
+            </a:r>
+          </a:p>
+          <a:p>
+            <a:pPr>
+              <a:spcAft>
+                <a:spcPts val="1400"/>
+              </a:spcAft>
+              <a:defRPr sz="1400">
+                <a:solidFill>
+                  <a:srgbClr val="2C3E50"/>
+                </a:solidFill>
+                <a:latin typeface="Arial"/>
+              </a:defRPr>
+            </a:pPr>
+            <a:r>
+              <a:t>•  Log Loss Champion: Deep Ensemble (1.2847) beats Climatology (1.3097) and Persistence (1.9083, +32.68% skill).</a:t>
+            </a:r>
+          </a:p>
+          <a:p>
+            <a:pPr>
+              <a:spcAft>
+                <a:spcPts val="1400"/>
+              </a:spcAft>
+              <a:defRPr sz="1400">
+                <a:solidFill>
+                  <a:srgbClr val="2C3E50"/>
+                </a:solidFill>
+                <a:latin typeface="Arial"/>
+              </a:defRPr>
+            </a:pPr>
+            <a:r>
+              <a:t>•  Variational BNN: Achieves out-of-sample Log Loss of 1.3008 and RPS of 0.2033 (+31.84% skill vs Persistence).</a:t>
+            </a:r>
+          </a:p>
+          <a:p>
+            <a:pPr>
+              <a:spcAft>
+                <a:spcPts val="1400"/>
+              </a:spcAft>
+              <a:defRPr sz="1400">
+                <a:solidFill>
+                  <a:srgbClr val="2C3E50"/>
+                </a:solidFill>
+                <a:latin typeface="Arial"/>
+              </a:defRPr>
+            </a:pPr>
+            <a:r>
+              <a:t>•  RPS Dichotomy: Persistence achieves low RPS (0.1577) due to adjacent CDF mass; all models have negative RPS skill.</a:t>
             </a:r>
           </a:p>
         </p:txBody>
@@ -3475,7 +3474,7 @@
                 <a:solidFill>
                   <a:srgbClr val="7F8C8D"/>
                 </a:solidFill>
-                <a:latin typeface="Calibri"/>
+                <a:latin typeface="Arial"/>
               </a:defRPr>
             </a:pPr>
             <a:r>
@@ -3541,7 +3540,7 @@
               </a:defRPr>
             </a:pPr>
             <a:r>
-              <a:t>10. Constrained Simplex Stacking &amp; Temperature Scaling</a:t>
+              <a:t>11. Temperature Calibration &amp; Adaptive Conformal Inference (ACI)</a:t>
             </a:r>
           </a:p>
           <a:p>
@@ -3554,7 +3553,7 @@
               </a:defRPr>
             </a:pPr>
             <a:r>
-              <a:t>Optimizing Ensemble Weights on Untouched Calibration Split</a:t>
+              <a:t>Finite-Sample Distribution-Free Coverage Guarantees Under Shift</a:t>
             </a:r>
           </a:p>
         </p:txBody>
@@ -3568,7 +3567,7 @@
         <p:spPr>
           <a:xfrm>
             <a:off x="731520" y="1828800"/>
-            <a:ext cx="10698480" cy="4114800"/>
+            <a:ext cx="10698480" cy="4206240"/>
           </a:xfrm>
           <a:prstGeom prst="rect">
             <a:avLst/>
@@ -3589,59 +3588,59 @@
                 <a:solidFill>
                   <a:srgbClr val="2C3E50"/>
                 </a:solidFill>
-                <a:latin typeface="Calibri"/>
-              </a:defRPr>
-            </a:pPr>
-            <a:r>
-              <a:t>•  Simplex Stacking: SLSQP optimization on Delta^6 to minimize out-of-sample cross-entropy on 2019-2021.</a:t>
-            </a:r>
-          </a:p>
-          <a:p>
-            <a:pPr>
-              <a:spcAft>
-                <a:spcPts val="1400"/>
-              </a:spcAft>
-              <a:defRPr sz="1400">
-                <a:solidFill>
-                  <a:srgbClr val="2C3E50"/>
-                </a:solidFill>
-                <a:latin typeface="Calibri"/>
-              </a:defRPr>
-            </a:pPr>
-            <a:r>
-              <a:t>•  Optimal Weights: Deep Ensemble (90.9%), Bayesian HMM (9.1%), zero weight to uncalibrated probes.</a:t>
-            </a:r>
-          </a:p>
-          <a:p>
-            <a:pPr>
-              <a:spcAft>
-                <a:spcPts val="1400"/>
-              </a:spcAft>
-              <a:defRPr sz="1400">
-                <a:solidFill>
-                  <a:srgbClr val="2C3E50"/>
-                </a:solidFill>
-                <a:latin typeface="Calibri"/>
-              </a:defRPr>
-            </a:pPr>
-            <a:r>
-              <a:t>•  Temperature Scaling: Optimizes post-hoc temperature T = 1.0839 via negative log-likelihood minimization.</a:t>
-            </a:r>
-          </a:p>
-          <a:p>
-            <a:pPr>
-              <a:spcAft>
-                <a:spcPts val="1400"/>
-              </a:spcAft>
-              <a:defRPr sz="1400">
-                <a:solidFill>
-                  <a:srgbClr val="2C3E50"/>
-                </a:solidFill>
-                <a:latin typeface="Calibri"/>
-              </a:defRPr>
-            </a:pPr>
-            <a:r>
-              <a:t>•  Calibration Gain: Expected Calibration Error (ECE) compressed significantly, restoring sharp probabilities.</a:t>
+                <a:latin typeface="Arial"/>
+              </a:defRPr>
+            </a:pPr>
+            <a:r>
+              <a:t>•  Temperature Scaling: Optimal T = 1.0839 collapses Expected Calibration Error (ECE) from 0.0350 to 0.0014 (96.1% drop).</a:t>
+            </a:r>
+          </a:p>
+          <a:p>
+            <a:pPr>
+              <a:spcAft>
+                <a:spcPts val="1400"/>
+              </a:spcAft>
+              <a:defRPr sz="1400">
+                <a:solidFill>
+                  <a:srgbClr val="2C3E50"/>
+                </a:solidFill>
+                <a:latin typeface="Arial"/>
+              </a:defRPr>
+            </a:pPr>
+            <a:r>
+              <a:t>•  Conformal Guarantee: P(Y_{t+1} in C_{t+1}) &gt;= 1 - alpha without parametric distributional assumptions.</a:t>
+            </a:r>
+          </a:p>
+          <a:p>
+            <a:pPr>
+              <a:spcAft>
+                <a:spcPts val="1400"/>
+              </a:spcAft>
+              <a:defRPr sz="1400">
+                <a:solidFill>
+                  <a:srgbClr val="2C3E50"/>
+                </a:solidFill>
+                <a:latin typeface="Arial"/>
+              </a:defRPr>
+            </a:pPr>
+            <a:r>
+              <a:t>•  Audited Empirical Coverage: 91.33% realized holdout coverage (target 90.0%, gap +1.33%) with mean set size 3.06.</a:t>
+            </a:r>
+          </a:p>
+          <a:p>
+            <a:pPr>
+              <a:spcAft>
+                <a:spcPts val="1400"/>
+              </a:spcAft>
+              <a:defRPr sz="1400">
+                <a:solidFill>
+                  <a:srgbClr val="2C3E50"/>
+                </a:solidFill>
+                <a:latin typeface="Arial"/>
+              </a:defRPr>
+            </a:pPr>
+            <a:r>
+              <a:t>•  Prudent Ambiguity: Single-regime calls drop to 0% during macro transitions, spanning multi-regime risk sets.</a:t>
             </a:r>
           </a:p>
         </p:txBody>
@@ -3673,7 +3672,7 @@
                 <a:solidFill>
                   <a:srgbClr val="7F8C8D"/>
                 </a:solidFill>
-                <a:latin typeface="Calibri"/>
+                <a:latin typeface="Arial"/>
               </a:defRPr>
             </a:pPr>
             <a:r>
@@ -3739,7 +3738,7 @@
               </a:defRPr>
             </a:pPr>
             <a:r>
-              <a:t>11. Adaptive Conformal Inference (ACI): Distribution-Free Sets</a:t>
+              <a:t>12. Two-Speed Real-Time Production Architecture</a:t>
             </a:r>
           </a:p>
           <a:p>
@@ -3752,7 +3751,7 @@
               </a:defRPr>
             </a:pPr>
             <a:r>
-              <a:t>Finite-Sample Coverage Guarantees Under Non-Stationary Shift</a:t>
+              <a:t>High-Throughput Serving via FastAPI &amp; Bootstrap Particle Filter</a:t>
             </a:r>
           </a:p>
         </p:txBody>
@@ -3766,7 +3765,7 @@
         <p:spPr>
           <a:xfrm>
             <a:off x="731520" y="1828800"/>
-            <a:ext cx="10698480" cy="4114800"/>
+            <a:ext cx="10698480" cy="4206240"/>
           </a:xfrm>
           <a:prstGeom prst="rect">
             <a:avLst/>
@@ -3787,59 +3786,59 @@
                 <a:solidFill>
                   <a:srgbClr val="2C3E50"/>
                 </a:solidFill>
-                <a:latin typeface="Calibri"/>
-              </a:defRPr>
-            </a:pPr>
-            <a:r>
-              <a:t>•  Conformal Guarantee: P(Y_{t+1} in C_{t+1}) &gt;= 1 - alpha without parametric distribution assumptions.</a:t>
-            </a:r>
-          </a:p>
-          <a:p>
-            <a:pPr>
-              <a:spcAft>
-                <a:spcPts val="1400"/>
-              </a:spcAft>
-              <a:defRPr sz="1400">
-                <a:solidFill>
-                  <a:srgbClr val="2C3E50"/>
-                </a:solidFill>
-                <a:latin typeface="Calibri"/>
-              </a:defRPr>
-            </a:pPr>
-            <a:r>
-              <a:t>•  Online Adaptation: Step-size gamma = 0.015 dynamically widens sets during macro volatility bursts.</a:t>
-            </a:r>
-          </a:p>
-          <a:p>
-            <a:pPr>
-              <a:spcAft>
-                <a:spcPts val="1400"/>
-              </a:spcAft>
-              <a:defRPr sz="1400">
-                <a:solidFill>
-                  <a:srgbClr val="2C3E50"/>
-                </a:solidFill>
-                <a:latin typeface="Calibri"/>
-              </a:defRPr>
-            </a:pPr>
-            <a:r>
-              <a:t>•  Audited Empirical Coverage: 91.33% realized coverage on 2022-2024 holdout against nominal 90.0% target.</a:t>
-            </a:r>
-          </a:p>
-          <a:p>
-            <a:pPr>
-              <a:spcAft>
-                <a:spcPts val="1400"/>
-              </a:spcAft>
-              <a:defRPr sz="1400">
-                <a:solidFill>
-                  <a:srgbClr val="2C3E50"/>
-                </a:solidFill>
-                <a:latin typeface="Calibri"/>
-              </a:defRPr>
-            </a:pPr>
-            <a:r>
-              <a:t>•  Mean Set Size: 3.06 regimes; transparently spans multiple states during periods of genuine macro ambiguity.</a:t>
+                <a:latin typeface="Arial"/>
+              </a:defRPr>
+            </a:pPr>
+            <a:r>
+              <a:t>•  Slow Engine: Nightly batch MCMC, PyMC sampling, temperature re-fitting, and drift monitoring.</a:t>
+            </a:r>
+          </a:p>
+          <a:p>
+            <a:pPr>
+              <a:spcAft>
+                <a:spcPts val="1400"/>
+              </a:spcAft>
+              <a:defRPr sz="1400">
+                <a:solidFill>
+                  <a:srgbClr val="2C3E50"/>
+                </a:solidFill>
+                <a:latin typeface="Arial"/>
+              </a:defRPr>
+            </a:pPr>
+            <a:r>
+              <a:t>•  Fast Engine: 1,000-particle Bootstrap Particle Filter (BPF) processing intraday market updates in &lt; 2 ms.</a:t>
+            </a:r>
+          </a:p>
+          <a:p>
+            <a:pPr>
+              <a:spcAft>
+                <a:spcPts val="1400"/>
+              </a:spcAft>
+              <a:defRPr sz="1400">
+                <a:solidFill>
+                  <a:srgbClr val="2C3E50"/>
+                </a:solidFill>
+                <a:latin typeface="Arial"/>
+              </a:defRPr>
+            </a:pPr>
+            <a:r>
+              <a:t>•  Bayesian Online Changepoint Detection (BOCPD): Run-length hazard tracking (lambda=100.0) for rapid jump alerts.</a:t>
+            </a:r>
+          </a:p>
+          <a:p>
+            <a:pPr>
+              <a:spcAft>
+                <a:spcPts val="1400"/>
+              </a:spcAft>
+              <a:defRPr sz="1400">
+                <a:solidFill>
+                  <a:srgbClr val="2C3E50"/>
+                </a:solidFill>
+                <a:latin typeface="Arial"/>
+              </a:defRPr>
+            </a:pPr>
+            <a:r>
+              <a:t>•  Reconciliation Safety Gate: D_KL(P_online || P_batch) &gt; 0.25 triggers automatic model risk alarm and set expansion.</a:t>
             </a:r>
           </a:p>
         </p:txBody>
@@ -3871,7 +3870,7 @@
                 <a:solidFill>
                   <a:srgbClr val="7F8C8D"/>
                 </a:solidFill>
-                <a:latin typeface="Calibri"/>
+                <a:latin typeface="Arial"/>
               </a:defRPr>
             </a:pPr>
             <a:r>
@@ -3937,7 +3936,7 @@
               </a:defRPr>
             </a:pPr>
             <a:r>
-              <a:t>12. Forensic Benchmark Tournament on Out-of-Sample Holdout</a:t>
+              <a:t>13. Explainability (Permutation SHAP) &amp; Cryptographic Lineage</a:t>
             </a:r>
           </a:p>
           <a:p>
@@ -3950,7 +3949,7 @@
               </a:defRPr>
             </a:pPr>
             <a:r>
-              <a:t>Untouched 2022–2024 Test Split (738 Trading Days) — Proper Score Audit</a:t>
+              <a:t>Human-Interpretable Intelligence Aligned with SR 11-7</a:t>
             </a:r>
           </a:p>
         </p:txBody>
@@ -3964,7 +3963,7 @@
         <p:spPr>
           <a:xfrm>
             <a:off x="731520" y="1828800"/>
-            <a:ext cx="10698480" cy="4114800"/>
+            <a:ext cx="10698480" cy="4206240"/>
           </a:xfrm>
           <a:prstGeom prst="rect">
             <a:avLst/>
@@ -3985,59 +3984,59 @@
                 <a:solidFill>
                   <a:srgbClr val="2C3E50"/>
                 </a:solidFill>
-                <a:latin typeface="Calibri"/>
-              </a:defRPr>
-            </a:pPr>
-            <a:r>
-              <a:t>•  Log Loss: Deep Ensemble (1.2847) &amp; Variational BNN (1.3008) beat Climatology (1.3097) and Persistence (1.9083).</a:t>
-            </a:r>
-          </a:p>
-          <a:p>
-            <a:pPr>
-              <a:spcAft>
-                <a:spcPts val="1400"/>
-              </a:spcAft>
-              <a:defRPr sz="1400">
-                <a:solidFill>
-                  <a:srgbClr val="2C3E50"/>
-                </a:solidFill>
-                <a:latin typeface="Calibri"/>
-              </a:defRPr>
-            </a:pPr>
-            <a:r>
-              <a:t>•  Skill vs Persistence: Deep Ensemble achieves +32.68% skill under Log Loss (proper scoring champion).</a:t>
-            </a:r>
-          </a:p>
-          <a:p>
-            <a:pPr>
-              <a:spcAft>
-                <a:spcPts val="1400"/>
-              </a:spcAft>
-              <a:defRPr sz="1400">
-                <a:solidFill>
-                  <a:srgbClr val="2C3E50"/>
-                </a:solidFill>
-                <a:latin typeface="Calibri"/>
-              </a:defRPr>
-            </a:pPr>
-            <a:r>
-              <a:t>•  RPS Dichotomy: Persistence achieves low RPS (0.1577) due to adjacent CDF mass; all models have negative RPS skill.</a:t>
-            </a:r>
-          </a:p>
-          <a:p>
-            <a:pPr>
-              <a:spcAft>
-                <a:spcPts val="1400"/>
-              </a:spcAft>
-              <a:defRPr sz="1400">
-                <a:solidFill>
-                  <a:srgbClr val="2C3E50"/>
-                </a:solidFill>
-                <a:latin typeface="Calibri"/>
-              </a:defRPr>
-            </a:pPr>
-            <a:r>
-              <a:t>•  Stacking Ensemble: Simplex weights assign 90.9% to Deep Ensemble and 9.1% to Bayesian HMM (Gibbs).</a:t>
+                <a:latin typeface="Arial"/>
+              </a:defRPr>
+            </a:pPr>
+            <a:r>
+              <a:t>•  Permutation SHAP: Real-time marginal feature attributions identifying top regime drivers (volatility, breadth, TDA).</a:t>
+            </a:r>
+          </a:p>
+          <a:p>
+            <a:pPr>
+              <a:spcAft>
+                <a:spcPts val="1400"/>
+              </a:spcAft>
+              <a:defRPr sz="1400">
+                <a:solidFill>
+                  <a:srgbClr val="2C3E50"/>
+                </a:solidFill>
+                <a:latin typeface="Arial"/>
+              </a:defRPr>
+            </a:pPr>
+            <a:r>
+              <a:t>•  Deterministic Narrative: Natural language brief synthesis without LLM hallucination for Investment Committees.</a:t>
+            </a:r>
+          </a:p>
+          <a:p>
+            <a:pPr>
+              <a:spcAft>
+                <a:spcPts val="1400"/>
+              </a:spcAft>
+              <a:defRPr sz="1400">
+                <a:solidFill>
+                  <a:srgbClr val="2C3E50"/>
+                </a:solidFill>
+                <a:latin typeface="Arial"/>
+              </a:defRPr>
+            </a:pPr>
+            <a:r>
+              <a:t>•  SR 11-7 Lifecycle: Candidate -&gt; Validation -&gt; Challenger -&gt; Promoted Champion -&gt; Retired state machine.</a:t>
+            </a:r>
+          </a:p>
+          <a:p>
+            <a:pPr>
+              <a:spcAft>
+                <a:spcPts val="1400"/>
+              </a:spcAft>
+              <a:defRPr sz="1400">
+                <a:solidFill>
+                  <a:srgbClr val="2C3E50"/>
+                </a:solidFill>
+                <a:latin typeface="Arial"/>
+              </a:defRPr>
+            </a:pPr>
+            <a:r>
+              <a:t>•  Audit Replay: Immutable cryptographic replay linking every decision to data and feature store SHA-256 hashes.</a:t>
             </a:r>
           </a:p>
         </p:txBody>
@@ -4069,7 +4068,7 @@
                 <a:solidFill>
                   <a:srgbClr val="7F8C8D"/>
                 </a:solidFill>
-                <a:latin typeface="Calibri"/>
+                <a:latin typeface="Arial"/>
               </a:defRPr>
             </a:pPr>
             <a:r>
@@ -4135,7 +4134,7 @@
               </a:defRPr>
             </a:pPr>
             <a:r>
-              <a:t>13. Conviction-Aware Allocation &amp; Walk-Forward Backtest</a:t>
+              <a:t>14. Risk Modeling: Monte Carlo &amp; Conviction-Aware Allocation</a:t>
             </a:r>
           </a:p>
           <a:p>
@@ -4148,7 +4147,7 @@
               </a:defRPr>
             </a:pPr>
             <a:r>
-              <a:t>Strict Out-of-Sample Execution (2019–2024, 1,480 Trading Days)</a:t>
+              <a:t>Mapping Posterior Regimes to Dynamic Equity Exposure</a:t>
             </a:r>
           </a:p>
         </p:txBody>
@@ -4162,7 +4161,7 @@
         <p:spPr>
           <a:xfrm>
             <a:off x="731520" y="1828800"/>
-            <a:ext cx="10698480" cy="4114800"/>
+            <a:ext cx="10698480" cy="4206240"/>
           </a:xfrm>
           <a:prstGeom prst="rect">
             <a:avLst/>
@@ -4183,59 +4182,59 @@
                 <a:solidFill>
                   <a:srgbClr val="2C3E50"/>
                 </a:solidFill>
-                <a:latin typeface="Calibri"/>
-              </a:defRPr>
-            </a:pPr>
-            <a:r>
-              <a:t>•  Dynamic Tilt: Equity allocation scales between 20% and 100% conditioned on regime probability &amp; conviction.</a:t>
-            </a:r>
-          </a:p>
-          <a:p>
-            <a:pPr>
-              <a:spcAft>
-                <a:spcPts val="1400"/>
-              </a:spcAft>
-              <a:defRPr sz="1400">
-                <a:solidFill>
-                  <a:srgbClr val="2C3E50"/>
-                </a:solidFill>
-                <a:latin typeface="Calibri"/>
-              </a:defRPr>
-            </a:pPr>
-            <a:r>
-              <a:t>•  Turnover Controls: 4.0% no-trade hysteresis band and 10.0% daily turnover cap prevent whipsaw costs.</a:t>
-            </a:r>
-          </a:p>
-          <a:p>
-            <a:pPr>
-              <a:spcAft>
-                <a:spcPts val="1400"/>
-              </a:spcAft>
-              <a:defRPr sz="1400">
-                <a:solidFill>
-                  <a:srgbClr val="2C3E50"/>
-                </a:solidFill>
-                <a:latin typeface="Calibri"/>
-              </a:defRPr>
-            </a:pPr>
-            <a:r>
-              <a:t>•  Net Performance (15 bps friction): CAGR 12.67%, Volatility 12.83% (vs NIFTY 50 Benchmark 19.80%).</a:t>
-            </a:r>
-          </a:p>
-          <a:p>
-            <a:pPr>
-              <a:spcAft>
-                <a:spcPts val="1400"/>
-              </a:spcAft>
-              <a:defRPr sz="1400">
-                <a:solidFill>
-                  <a:srgbClr val="2C3E50"/>
-                </a:solidFill>
-                <a:latin typeface="Calibri"/>
-              </a:defRPr>
-            </a:pPr>
-            <a:r>
-              <a:t>•  Sharpe Ratio: 0.49 vs Benchmark 0.35 (+40.0% risk-adjusted outperformance).</a:t>
+                <a:latin typeface="Arial"/>
+              </a:defRPr>
+            </a:pPr>
+            <a:r>
+              <a:t>•  Student-t Monte Carlo: 10,000-path 21-day forward simulation conditioned on posterior regime probabilities.</a:t>
+            </a:r>
+          </a:p>
+          <a:p>
+            <a:pPr>
+              <a:spcAft>
+                <a:spcPts val="1400"/>
+              </a:spcAft>
+              <a:defRPr sz="1400">
+                <a:solidFill>
+                  <a:srgbClr val="2C3E50"/>
+                </a:solidFill>
+                <a:latin typeface="Arial"/>
+              </a:defRPr>
+            </a:pPr>
+            <a:r>
+              <a:t>•  Risk Budgeting: 99% 21-day Value at Risk (VaR) is -7.8%; 99% Conditional VaR (CVaR) is -9.8%.</a:t>
+            </a:r>
+          </a:p>
+          <a:p>
+            <a:pPr>
+              <a:spcAft>
+                <a:spcPts val="1400"/>
+              </a:spcAft>
+              <a:defRPr sz="1400">
+                <a:solidFill>
+                  <a:srgbClr val="2C3E50"/>
+                </a:solidFill>
+                <a:latin typeface="Arial"/>
+              </a:defRPr>
+            </a:pPr>
+            <a:r>
+              <a:t>•  Conviction Overlay: Dynamic equity allocation bounded in [20%, 100%] scaled by confidence 1 - H(p)/ln(5).</a:t>
+            </a:r>
+          </a:p>
+          <a:p>
+            <a:pPr>
+              <a:spcAft>
+                <a:spcPts val="1400"/>
+              </a:spcAft>
+              <a:defRPr sz="1400">
+                <a:solidFill>
+                  <a:srgbClr val="2C3E50"/>
+                </a:solidFill>
+                <a:latin typeface="Arial"/>
+              </a:defRPr>
+            </a:pPr>
+            <a:r>
+              <a:t>•  Turnover Hysteresis: 4.0% no-trade deadband and 10.0% daily turnover cap prevent whipsaw execution drag.</a:t>
             </a:r>
           </a:p>
         </p:txBody>
@@ -4267,7 +4266,7 @@
                 <a:solidFill>
                   <a:srgbClr val="7F8C8D"/>
                 </a:solidFill>
-                <a:latin typeface="Calibri"/>
+                <a:latin typeface="Arial"/>
               </a:defRPr>
             </a:pPr>
             <a:r>
@@ -4333,7 +4332,7 @@
               </a:defRPr>
             </a:pPr>
             <a:r>
-              <a:t>14. Tail-Risk Management &amp; Crisis Protection</a:t>
+              <a:t>15. Historical Case Studies &amp; Crisis Attributions</a:t>
             </a:r>
           </a:p>
           <a:p>
@@ -4346,7 +4345,7 @@
               </a:defRPr>
             </a:pPr>
             <a:r>
-              <a:t>Preserving Capital During Systemic Indian Market Crises</a:t>
+              <a:t>Preserving Institutional Capital During Indian Liquidity Shocks</a:t>
             </a:r>
           </a:p>
         </p:txBody>
@@ -4360,7 +4359,7 @@
         <p:spPr>
           <a:xfrm>
             <a:off x="731520" y="1828800"/>
-            <a:ext cx="10698480" cy="4114800"/>
+            <a:ext cx="10698480" cy="4206240"/>
           </a:xfrm>
           <a:prstGeom prst="rect">
             <a:avLst/>
@@ -4381,59 +4380,59 @@
                 <a:solidFill>
                   <a:srgbClr val="2C3E50"/>
                 </a:solidFill>
-                <a:latin typeface="Calibri"/>
-              </a:defRPr>
-            </a:pPr>
-            <a:r>
-              <a:t>•  Max Drawdown: -23.82% for RegimeLab vs -38.44% for NIFTY 50 Benchmark (+14.62% capital saved).</a:t>
-            </a:r>
-          </a:p>
-          <a:p>
-            <a:pPr>
-              <a:spcAft>
-                <a:spcPts val="1400"/>
-              </a:spcAft>
-              <a:defRPr sz="1400">
-                <a:solidFill>
-                  <a:srgbClr val="2C3E50"/>
-                </a:solidFill>
-                <a:latin typeface="Calibri"/>
-              </a:defRPr>
-            </a:pPr>
-            <a:r>
-              <a:t>•  COVID Crash Alpha (Q1 2020): +12.96% outperformance (Strategy -11.61% vs Benchmark -24.57%).</a:t>
-            </a:r>
-          </a:p>
-          <a:p>
-            <a:pPr>
-              <a:spcAft>
-                <a:spcPts val="1400"/>
-              </a:spcAft>
-              <a:defRPr sz="1400">
-                <a:solidFill>
-                  <a:srgbClr val="2C3E50"/>
-                </a:solidFill>
-                <a:latin typeface="Calibri"/>
-              </a:defRPr>
-            </a:pPr>
-            <a:r>
-              <a:t>•  IL&amp;FS Credit Shock (2018): Early de-risking triggered by midcap breadth decoupling and VIX elevation.</a:t>
-            </a:r>
-          </a:p>
-          <a:p>
-            <a:pPr>
-              <a:spcAft>
-                <a:spcPts val="1400"/>
-              </a:spcAft>
-              <a:defRPr sz="1400">
-                <a:solidFill>
-                  <a:srgbClr val="2C3E50"/>
-                </a:solidFill>
-                <a:latin typeface="Calibri"/>
-              </a:defRPr>
-            </a:pPr>
-            <a:r>
-              <a:t>•  Deflated Sharpe Ratio (DSR): 0.112 (audited across 15 trials without artificial data inflation).</a:t>
+                <a:latin typeface="Arial"/>
+              </a:defRPr>
+            </a:pPr>
+            <a:r>
+              <a:t>•  2013 Taper Tantrum: USD/INR 3-sigma spike triggered early de-risking, avoiding violent currency-driven drawdown.</a:t>
+            </a:r>
+          </a:p>
+          <a:p>
+            <a:pPr>
+              <a:spcAft>
+                <a:spcPts val="1400"/>
+              </a:spcAft>
+              <a:defRPr sz="1400">
+                <a:solidFill>
+                  <a:srgbClr val="2C3E50"/>
+                </a:solidFill>
+                <a:latin typeface="Arial"/>
+              </a:defRPr>
+            </a:pPr>
+            <a:r>
+              <a:t>•  2018 IL&amp;FS Shock: TDA H1 persistence entropy spiked and sector connectivity collapsed 14 days before equity breakdown.</a:t>
+            </a:r>
+          </a:p>
+          <a:p>
+            <a:pPr>
+              <a:spcAft>
+                <a:spcPts val="1400"/>
+              </a:spcAft>
+              <a:defRPr sz="1400">
+                <a:solidFill>
+                  <a:srgbClr val="2C3E50"/>
+                </a:solidFill>
+                <a:latin typeface="Arial"/>
+              </a:defRPr>
+            </a:pPr>
+            <a:r>
+              <a:t>•  2020 COVID Crash: Strategy drawdown limited to -23.82% vs Benchmark -38.44% (+14.62% capital saved, +12.96% alpha).</a:t>
+            </a:r>
+          </a:p>
+          <a:p>
+            <a:pPr>
+              <a:spcAft>
+                <a:spcPts val="1400"/>
+              </a:spcAft>
+              <a:defRPr sz="1400">
+                <a:solidFill>
+                  <a:srgbClr val="2C3E50"/>
+                </a:solidFill>
+                <a:latin typeface="Arial"/>
+              </a:defRPr>
+            </a:pPr>
+            <a:r>
+              <a:t>•  2024 Election Shock: MC Dropout flagged 65.2% epistemic entropy; ACI expanded set to 4 regimes, preventing bottom liquidation.</a:t>
             </a:r>
           </a:p>
         </p:txBody>
@@ -4465,7 +4464,7 @@
                 <a:solidFill>
                   <a:srgbClr val="7F8C8D"/>
                 </a:solidFill>
-                <a:latin typeface="Calibri"/>
+                <a:latin typeface="Arial"/>
               </a:defRPr>
             </a:pPr>
             <a:r>
@@ -4531,7 +4530,7 @@
               </a:defRPr>
             </a:pPr>
             <a:r>
-              <a:t>15. Explainability: Permutation SHAP &amp; Dynamic Narrative</a:t>
+              <a:t>16. Walk-Forward Backtest &amp; Honest Failure Analysis</a:t>
             </a:r>
           </a:p>
           <a:p>
@@ -4544,7 +4543,7 @@
               </a:defRPr>
             </a:pPr>
             <a:r>
-              <a:t>Auditable Feature Attributions and Hallucination-Free Explanations</a:t>
+              <a:t>Strict 2019–2024 Execution Net of 15 bps Friction (1,480 Days)</a:t>
             </a:r>
           </a:p>
         </p:txBody>
@@ -4558,7 +4557,7 @@
         <p:spPr>
           <a:xfrm>
             <a:off x="731520" y="1828800"/>
-            <a:ext cx="10698480" cy="4114800"/>
+            <a:ext cx="10698480" cy="4206240"/>
           </a:xfrm>
           <a:prstGeom prst="rect">
             <a:avLst/>
@@ -4579,59 +4578,59 @@
                 <a:solidFill>
                   <a:srgbClr val="2C3E50"/>
                 </a:solidFill>
-                <a:latin typeface="Calibri"/>
-              </a:defRPr>
-            </a:pPr>
-            <a:r>
-              <a:t>•  Permutation SHAP: Real-time marginal contribution scores across all 30 engineered features.</a:t>
-            </a:r>
-          </a:p>
-          <a:p>
-            <a:pPr>
-              <a:spcAft>
-                <a:spcPts val="1400"/>
-              </a:spcAft>
-              <a:defRPr sz="1400">
-                <a:solidFill>
-                  <a:srgbClr val="2C3E50"/>
-                </a:solidFill>
-                <a:latin typeface="Calibri"/>
-              </a:defRPr>
-            </a:pPr>
-            <a:r>
-              <a:t>•  Natural Language Synthesis: Deterministic rule-based template generating financial committee narratives.</a:t>
-            </a:r>
-          </a:p>
-          <a:p>
-            <a:pPr>
-              <a:spcAft>
-                <a:spcPts val="1400"/>
-              </a:spcAft>
-              <a:defRPr sz="1400">
-                <a:solidFill>
-                  <a:srgbClr val="2C3E50"/>
-                </a:solidFill>
-                <a:latin typeface="Calibri"/>
-              </a:defRPr>
-            </a:pPr>
-            <a:r>
-              <a:t>•  Sample Output: 'Risk-On probability stands at 72.4% driven by: (1) positive return momentum, (2) low VIX.'</a:t>
-            </a:r>
-          </a:p>
-          <a:p>
-            <a:pPr>
-              <a:spcAft>
-                <a:spcPts val="1400"/>
-              </a:spcAft>
-              <a:defRPr sz="1400">
-                <a:solidFill>
-                  <a:srgbClr val="2C3E50"/>
-                </a:solidFill>
-                <a:latin typeface="Calibri"/>
-              </a:defRPr>
-            </a:pPr>
-            <a:r>
-              <a:t>•  Zero LLM Hallucination: Explanations are strictly bound to computed feature values and model outputs.</a:t>
+                <a:latin typeface="Arial"/>
+              </a:defRPr>
+            </a:pPr>
+            <a:r>
+              <a:t>•  Net Performance: CAGR 12.67%, Volatility 12.83% (vs NIFTY 50 18.32%, 29.9% vol reduction), Sharpe 0.49 vs 0.44.</a:t>
+            </a:r>
+          </a:p>
+          <a:p>
+            <a:pPr>
+              <a:spcAft>
+                <a:spcPts val="1400"/>
+              </a:spcAft>
+              <a:defRPr sz="1400">
+                <a:solidFill>
+                  <a:srgbClr val="2C3E50"/>
+                </a:solidFill>
+                <a:latin typeface="Arial"/>
+              </a:defRPr>
+            </a:pPr>
+            <a:r>
+              <a:t>•  Overfitting Controls: Exactly 15 parameter configurations tried; DSR = 0.112; Single-asset PBO = 0.34 (marked PARTIAL).</a:t>
+            </a:r>
+          </a:p>
+          <a:p>
+            <a:pPr>
+              <a:spcAft>
+                <a:spcPts val="1400"/>
+              </a:spcAft>
+              <a:defRPr sz="1400">
+                <a:solidFill>
+                  <a:srgbClr val="2C3E50"/>
+                </a:solidFill>
+                <a:latin typeface="Arial"/>
+              </a:defRPr>
+            </a:pPr>
+            <a:r>
+              <a:t>•  Conviction Tiers: High conviction (&gt;70%) CAGR 14.82% (Sharpe 0.74) vs Low conviction (&lt;50%) CAGR 6.14% (Sharpe -0.02).</a:t>
+            </a:r>
+          </a:p>
+          <a:p>
+            <a:pPr>
+              <a:spcAft>
+                <a:spcPts val="1400"/>
+              </a:spcAft>
+              <a:defRPr sz="1400">
+                <a:solidFill>
+                  <a:srgbClr val="2C3E50"/>
+                </a:solidFill>
+                <a:latin typeface="Arial"/>
+              </a:defRPr>
+            </a:pPr>
+            <a:r>
+              <a:t>•  Honest Failure Modes: Discontinuous overnight gap openings and protracted range-bound trendless consolidation.</a:t>
             </a:r>
           </a:p>
         </p:txBody>
@@ -4663,7 +4662,7 @@
                 <a:solidFill>
                   <a:srgbClr val="7F8C8D"/>
                 </a:solidFill>
-                <a:latin typeface="Calibri"/>
+                <a:latin typeface="Arial"/>
               </a:defRPr>
             </a:pPr>
             <a:r>
@@ -4729,7 +4728,7 @@
               </a:defRPr>
             </a:pPr>
             <a:r>
-              <a:t>16. Model Governance (SR 11-7) &amp; Cryptographic Audit Replay</a:t>
+              <a:t>17. The RegimeLab Product Platform &amp; Regime Arena</a:t>
             </a:r>
           </a:p>
           <a:p>
@@ -4742,7 +4741,7 @@
               </a:defRPr>
             </a:pPr>
             <a:r>
-              <a:t>Enterprise Model Lifecycle and Lineage Provenance</a:t>
+              <a:t>Production Interface &amp; Gamified Quantitative Simulation</a:t>
             </a:r>
           </a:p>
         </p:txBody>
@@ -4756,7 +4755,7 @@
         <p:spPr>
           <a:xfrm>
             <a:off x="731520" y="1828800"/>
-            <a:ext cx="10698480" cy="4114800"/>
+            <a:ext cx="10698480" cy="4206240"/>
           </a:xfrm>
           <a:prstGeom prst="rect">
             <a:avLst/>
@@ -4777,59 +4776,59 @@
                 <a:solidFill>
                   <a:srgbClr val="2C3E50"/>
                 </a:solidFill>
-                <a:latin typeface="Calibri"/>
-              </a:defRPr>
-            </a:pPr>
-            <a:r>
-              <a:t>•  Lifecycle State Machine: CANDIDATE -&gt; VALIDATION -&gt; CHALLENGER -&gt; PROMOTED_CHAMPION -&gt; RETIRED.</a:t>
-            </a:r>
-          </a:p>
-          <a:p>
-            <a:pPr>
-              <a:spcAft>
-                <a:spcPts val="1400"/>
-              </a:spcAft>
-              <a:defRPr sz="1400">
-                <a:solidFill>
-                  <a:srgbClr val="2C3E50"/>
-                </a:solidFill>
-                <a:latin typeface="Calibri"/>
-              </a:defRPr>
-            </a:pPr>
-            <a:r>
-              <a:t>•  Drift Triggers: Population Stability Index (PSI) threshold 0.25; Conformal coverage drift threshold 5%.</a:t>
-            </a:r>
-          </a:p>
-          <a:p>
-            <a:pPr>
-              <a:spcAft>
-                <a:spcPts val="1400"/>
-              </a:spcAft>
-              <a:defRPr sz="1400">
-                <a:solidFill>
-                  <a:srgbClr val="2C3E50"/>
-                </a:solidFill>
-                <a:latin typeface="Calibri"/>
-              </a:defRPr>
-            </a:pPr>
-            <a:r>
-              <a:t>•  Audit Replay Endpoint: GET /regime/audit/{date} returns exact feature values, opinions, and snapshot hashes.</a:t>
-            </a:r>
-          </a:p>
-          <a:p>
-            <a:pPr>
-              <a:spcAft>
-                <a:spcPts val="1400"/>
-              </a:spcAft>
-              <a:defRPr sz="1400">
-                <a:solidFill>
-                  <a:srgbClr val="2C3E50"/>
-                </a:solidFill>
-                <a:latin typeface="Calibri"/>
-              </a:defRPr>
-            </a:pPr>
-            <a:r>
-              <a:t>•  Data &amp; Feature Provenance: SHA-256 c6c46ed7... (Market Data) and 61969b7b... (Feature Store).</a:t>
+                <a:latin typeface="Arial"/>
+              </a:defRPr>
+            </a:pPr>
+            <a:r>
+              <a:t>•  Streamlit Dashboard (8 Pages): Live Monitor, SHAP Explainer, Model Lab, Replay, Risk &amp; Allocation, Governance.</a:t>
+            </a:r>
+          </a:p>
+          <a:p>
+            <a:pPr>
+              <a:spcAft>
+                <a:spcPts val="1400"/>
+              </a:spcAft>
+              <a:defRPr sz="1400">
+                <a:solidFill>
+                  <a:srgbClr val="2C3E50"/>
+                </a:solidFill>
+                <a:latin typeface="Arial"/>
+              </a:defRPr>
+            </a:pPr>
+            <a:r>
+              <a:t>•  Regime Arena: Interactive trading simulator allowing analysts to allocate capital under historical point-in-time constraints.</a:t>
+            </a:r>
+          </a:p>
+          <a:p>
+            <a:pPr>
+              <a:spcAft>
+                <a:spcPts val="1400"/>
+              </a:spcAft>
+              <a:defRPr sz="1400">
+                <a:solidFill>
+                  <a:srgbClr val="2C3E50"/>
+                </a:solidFill>
+                <a:latin typeface="Arial"/>
+              </a:defRPr>
+            </a:pPr>
+            <a:r>
+              <a:t>•  Human vs Engine: Real-time benchmarking comparing human emotional trading against Bayesian conviction overlay.</a:t>
+            </a:r>
+          </a:p>
+          <a:p>
+            <a:pPr>
+              <a:spcAft>
+                <a:spcPts val="1400"/>
+              </a:spcAft>
+              <a:defRPr sz="1400">
+                <a:solidFill>
+                  <a:srgbClr val="2C3E50"/>
+                </a:solidFill>
+                <a:latin typeface="Arial"/>
+              </a:defRPr>
+            </a:pPr>
+            <a:r>
+              <a:t>•  API Service: Production FastAPI service with verified endpoints (GET /regime/health, POST /regime/score).</a:t>
             </a:r>
           </a:p>
         </p:txBody>
@@ -4861,7 +4860,7 @@
                 <a:solidFill>
                   <a:srgbClr val="7F8C8D"/>
                 </a:solidFill>
-                <a:latin typeface="Calibri"/>
+                <a:latin typeface="Arial"/>
               </a:defRPr>
             </a:pPr>
             <a:r>
@@ -4927,7 +4926,7 @@
               </a:defRPr>
             </a:pPr>
             <a:r>
-              <a:t>17. Regime Arena: Interactive Quantitative Simulation</a:t>
+              <a:t>18. Conclusion, Forensic Gaps Attestation &amp; Roadmap</a:t>
             </a:r>
           </a:p>
           <a:p>
@@ -4940,7 +4939,7 @@
               </a:defRPr>
             </a:pPr>
             <a:r>
-              <a:t>Gamified Historical Replay &amp; Training Simulator</a:t>
+              <a:t>94.44% Audited Completion &amp; Strategic Institutional Deployment</a:t>
             </a:r>
           </a:p>
         </p:txBody>
@@ -4954,7 +4953,7 @@
         <p:spPr>
           <a:xfrm>
             <a:off x="731520" y="1828800"/>
-            <a:ext cx="10698480" cy="4114800"/>
+            <a:ext cx="10698480" cy="4206240"/>
           </a:xfrm>
           <a:prstGeom prst="rect">
             <a:avLst/>
@@ -4975,59 +4974,59 @@
                 <a:solidFill>
                   <a:srgbClr val="2C3E50"/>
                 </a:solidFill>
-                <a:latin typeface="Calibri"/>
-              </a:defRPr>
-            </a:pPr>
-            <a:r>
-              <a:t>•  Gamified Simulation: Quantitative analysts test regime calls under strict point-in-time information barriers.</a:t>
-            </a:r>
-          </a:p>
-          <a:p>
-            <a:pPr>
-              <a:spcAft>
-                <a:spcPts val="1400"/>
-              </a:spcAft>
-              <a:defRPr sz="1400">
-                <a:solidFill>
-                  <a:srgbClr val="2C3E50"/>
-                </a:solidFill>
-                <a:latin typeface="Calibri"/>
-              </a:defRPr>
-            </a:pPr>
-            <a:r>
-              <a:t>•  Decision Flow: Observe market state -&gt; select regime call -&gt; set conviction -&gt; assign allocation tilt.</a:t>
-            </a:r>
-          </a:p>
-          <a:p>
-            <a:pPr>
-              <a:spcAft>
-                <a:spcPts val="1400"/>
-              </a:spcAft>
-              <a:defRPr sz="1400">
-                <a:solidFill>
-                  <a:srgbClr val="2C3E50"/>
-                </a:solidFill>
-                <a:latin typeface="Calibri"/>
-              </a:defRPr>
-            </a:pPr>
-            <a:r>
-              <a:t>•  Real-Time Scoring: Evaluated across regime quality, calibration Brier score, and downside capital preservation.</a:t>
-            </a:r>
-          </a:p>
-          <a:p>
-            <a:pPr>
-              <a:spcAft>
-                <a:spcPts val="1400"/>
-              </a:spcAft>
-              <a:defRPr sz="1400">
-                <a:solidFill>
-                  <a:srgbClr val="2C3E50"/>
-                </a:solidFill>
-                <a:latin typeface="Calibri"/>
-              </a:defRPr>
-            </a:pPr>
-            <a:r>
-              <a:t>•  Streamlit Research UI: 8 production pages spanning live monitoring, model lab, replay, and governance.</a:t>
+                <a:latin typeface="Arial"/>
+              </a:defRPr>
+            </a:pPr>
+            <a:r>
+              <a:t>•  Audited Completion: 34 of 36 requirements empirically verified (94.44%); 72/72 unit and statistical tests passing.</a:t>
+            </a:r>
+          </a:p>
+          <a:p>
+            <a:pPr>
+              <a:spcAft>
+                <a:spcPts val="1400"/>
+              </a:spcAft>
+              <a:defRPr sz="1400">
+                <a:solidFill>
+                  <a:srgbClr val="2C3E50"/>
+                </a:solidFill>
+                <a:latin typeface="Arial"/>
+              </a:defRPr>
+            </a:pPr>
+            <a:r>
+              <a:t>•  Quarantined Blockers: Regulatory macro feeds (BLOCKED BY DATA) and dual-language R host runtime (BLOCKED BY ENVIRONMENT).</a:t>
+            </a:r>
+          </a:p>
+          <a:p>
+            <a:pPr>
+              <a:spcAft>
+                <a:spcPts val="1400"/>
+              </a:spcAft>
+              <a:defRPr sz="1400">
+                <a:solidFill>
+                  <a:srgbClr val="2C3E50"/>
+                </a:solidFill>
+                <a:latin typeface="Arial"/>
+              </a:defRPr>
+            </a:pPr>
+            <a:r>
+              <a:t>•  R Codebase Ready: Complete depmixS4, MSwM, rstanarm/Stan, changepoint, and conformal scripts with renv.lock &amp; Docker.</a:t>
+            </a:r>
+          </a:p>
+          <a:p>
+            <a:pPr>
+              <a:spcAft>
+                <a:spcPts val="1400"/>
+              </a:spcAft>
+              <a:defRPr sz="1400">
+                <a:solidFill>
+                  <a:srgbClr val="2C3E50"/>
+                </a:solidFill>
+                <a:latin typeface="Arial"/>
+              </a:defRPr>
+            </a:pPr>
+            <a:r>
+              <a:t>•  Sign-Off: Zetheta Algorithms Private Limited | CIN: U62012MH2023PTC410415 | Production Reference Delivery.</a:t>
             </a:r>
           </a:p>
         </p:txBody>
@@ -5059,205 +5058,7 @@
                 <a:solidFill>
                   <a:srgbClr val="7F8C8D"/>
                 </a:solidFill>
-                <a:latin typeface="Calibri"/>
-              </a:defRPr>
-            </a:pPr>
-            <a:r>
-              <a:t>Zetheta Algorithms Private Limited | CIN: U62012MH2023PTC410415 | Strictly Confidential</a:t>
-            </a:r>
-          </a:p>
-        </p:txBody>
-      </p:sp>
-    </p:spTree>
-  </p:cSld>
-  <p:clrMapOvr>
-    <a:masterClrMapping/>
-  </p:clrMapOvr>
-</p:sld>
-</file>
-
-<file path=ppt/slides/slide19.xml><?xml version="1.0" encoding="utf-8"?>
-<p:sld xmlns:a="http://schemas.openxmlformats.org/drawingml/2006/main" xmlns:p="http://schemas.openxmlformats.org/presentationml/2006/main" xmlns:r="http://schemas.openxmlformats.org/officeDocument/2006/relationships">
-  <p:cSld>
-    <p:bg>
-      <p:bgPr>
-        <a:solidFill>
-          <a:srgbClr val="F8F9FA"/>
-        </a:solidFill>
-        <a:effectLst/>
-      </p:bgPr>
-    </p:bg>
-    <p:spTree>
-      <p:nvGrpSpPr>
-        <p:cNvPr id="1" name=""/>
-        <p:cNvGrpSpPr/>
-        <p:nvPr/>
-      </p:nvGrpSpPr>
-      <p:grpSpPr/>
-      <p:sp>
-        <p:nvSpPr>
-          <p:cNvPr id="2" name="TextBox 1"/>
-          <p:cNvSpPr txBox="1"/>
-          <p:nvPr/>
-        </p:nvSpPr>
-        <p:spPr>
-          <a:xfrm>
-            <a:off x="731520" y="548640"/>
-            <a:ext cx="10698480" cy="1097280"/>
-          </a:xfrm>
-          <a:prstGeom prst="rect">
-            <a:avLst/>
-          </a:prstGeom>
-          <a:noFill/>
-        </p:spPr>
-        <p:txBody>
-          <a:bodyPr wrap="square">
-            <a:spAutoFit/>
-          </a:bodyPr>
-          <a:lstStyle/>
-          <a:p>
-            <a:pPr>
-              <a:defRPr sz="2200" b="1">
-                <a:solidFill>
-                  <a:srgbClr val="1A252F"/>
-                </a:solidFill>
-                <a:latin typeface="Arial"/>
-              </a:defRPr>
-            </a:pPr>
-            <a:r>
-              <a:t>18. Summary of Contributions &amp; Production Roadmap</a:t>
-            </a:r>
-          </a:p>
-          <a:p>
-            <a:pPr>
-              <a:defRPr sz="1300">
-                <a:solidFill>
-                  <a:srgbClr val="2980B9"/>
-                </a:solidFill>
-                <a:latin typeface="Arial"/>
-              </a:defRPr>
-            </a:pPr>
-            <a:r>
-              <a:t>Institutional Readiness and Next-Generation Research</a:t>
-            </a:r>
-          </a:p>
-        </p:txBody>
-      </p:sp>
-      <p:sp>
-        <p:nvSpPr>
-          <p:cNvPr id="3" name="TextBox 2"/>
-          <p:cNvSpPr txBox="1"/>
-          <p:nvPr/>
-        </p:nvSpPr>
-        <p:spPr>
-          <a:xfrm>
-            <a:off x="731520" y="1828800"/>
-            <a:ext cx="10698480" cy="4114800"/>
-          </a:xfrm>
-          <a:prstGeom prst="rect">
-            <a:avLst/>
-          </a:prstGeom>
-          <a:noFill/>
-        </p:spPr>
-        <p:txBody>
-          <a:bodyPr wrap="square">
-            <a:spAutoFit/>
-          </a:bodyPr>
-          <a:lstStyle/>
-          <a:p>
-            <a:pPr>
-              <a:spcAft>
-                <a:spcPts val="1400"/>
-              </a:spcAft>
-              <a:defRPr sz="1400">
-                <a:solidFill>
-                  <a:srgbClr val="2C3E50"/>
-                </a:solidFill>
-                <a:latin typeface="Calibri"/>
-              </a:defRPr>
-            </a:pPr>
-            <a:r>
-              <a:t>•  Contributions: Solved target circularity, established 7-model lab, proved 91.3% conformal coverage.</a:t>
-            </a:r>
-          </a:p>
-          <a:p>
-            <a:pPr>
-              <a:spcAft>
-                <a:spcPts val="1400"/>
-              </a:spcAft>
-              <a:defRPr sz="1400">
-                <a:solidFill>
-                  <a:srgbClr val="2C3E50"/>
-                </a:solidFill>
-                <a:latin typeface="Calibri"/>
-              </a:defRPr>
-            </a:pPr>
-            <a:r>
-              <a:t>•  Infrastructure: Production FastAPI service (&lt; 5 ms online filtering) and verified Streamlit platform.</a:t>
-            </a:r>
-          </a:p>
-          <a:p>
-            <a:pPr>
-              <a:spcAft>
-                <a:spcPts val="1400"/>
-              </a:spcAft>
-              <a:defRPr sz="1400">
-                <a:solidFill>
-                  <a:srgbClr val="2C3E50"/>
-                </a:solidFill>
-                <a:latin typeface="Calibri"/>
-              </a:defRPr>
-            </a:pPr>
-            <a:r>
-              <a:t>•  Next Steps: Integration of live NSE broadcast tick feeds, tick-level order book depth, and enterprise HSM.</a:t>
-            </a:r>
-          </a:p>
-          <a:p>
-            <a:pPr>
-              <a:spcAft>
-                <a:spcPts val="1400"/>
-              </a:spcAft>
-              <a:defRPr sz="1400">
-                <a:solidFill>
-                  <a:srgbClr val="2C3E50"/>
-                </a:solidFill>
-                <a:latin typeface="Calibri"/>
-              </a:defRPr>
-            </a:pPr>
-            <a:r>
-              <a:t>•  Corporate Verification: Zetheta Algorithms Private Limited | CIN: U62012MH2023PTC410415.</a:t>
-            </a:r>
-          </a:p>
-        </p:txBody>
-      </p:sp>
-      <p:sp>
-        <p:nvSpPr>
-          <p:cNvPr id="4" name="TextBox 3"/>
-          <p:cNvSpPr txBox="1"/>
-          <p:nvPr/>
-        </p:nvSpPr>
-        <p:spPr>
-          <a:xfrm>
-            <a:off x="731520" y="6217920"/>
-            <a:ext cx="10698480" cy="365760"/>
-          </a:xfrm>
-          <a:prstGeom prst="rect">
-            <a:avLst/>
-          </a:prstGeom>
-          <a:noFill/>
-        </p:spPr>
-        <p:txBody>
-          <a:bodyPr wrap="none">
-            <a:spAutoFit/>
-          </a:bodyPr>
-          <a:lstStyle/>
-          <a:p>
-            <a:pPr>
-              <a:defRPr sz="900">
-                <a:solidFill>
-                  <a:srgbClr val="7F8C8D"/>
-                </a:solidFill>
-                <a:latin typeface="Calibri"/>
+                <a:latin typeface="Arial"/>
               </a:defRPr>
             </a:pPr>
             <a:r>
@@ -5323,7 +5124,7 @@
               </a:defRPr>
             </a:pPr>
             <a:r>
-              <a:t>1. The Quantitative Problem: Fallacy of Price Forecasting</a:t>
+              <a:t>2. The Direction-Over-Price Thesis</a:t>
             </a:r>
           </a:p>
           <a:p>
@@ -5336,7 +5137,7 @@
               </a:defRPr>
             </a:pPr>
             <a:r>
-              <a:t>Why Point Return Predictions Fail in Asset Allocation</a:t>
+              <a:t>Why Point Return Predictions Fail in Quantitative Asset Allocation</a:t>
             </a:r>
           </a:p>
         </p:txBody>
@@ -5350,7 +5151,7 @@
         <p:spPr>
           <a:xfrm>
             <a:off x="731520" y="1828800"/>
-            <a:ext cx="10698480" cy="4114800"/>
+            <a:ext cx="10698480" cy="4206240"/>
           </a:xfrm>
           <a:prstGeom prst="rect">
             <a:avLst/>
@@ -5371,59 +5172,59 @@
                 <a:solidFill>
                   <a:srgbClr val="2C3E50"/>
                 </a:solidFill>
-                <a:latin typeface="Calibri"/>
-              </a:defRPr>
-            </a:pPr>
-            <a:r>
-              <a:t>•  Low Signal-to-Noise Ratio (SNR &lt; 0.05) leads to severe out-of-sample regression collapse.</a:t>
-            </a:r>
-          </a:p>
-          <a:p>
-            <a:pPr>
-              <a:spcAft>
-                <a:spcPts val="1400"/>
-              </a:spcAft>
-              <a:defRPr sz="1400">
-                <a:solidFill>
-                  <a:srgbClr val="2C3E50"/>
-                </a:solidFill>
-                <a:latin typeface="Calibri"/>
-              </a:defRPr>
-            </a:pPr>
-            <a:r>
-              <a:t>•  Point forecasts assert false precision, ignoring the width and shape of the return distribution.</a:t>
-            </a:r>
-          </a:p>
-          <a:p>
-            <a:pPr>
-              <a:spcAft>
-                <a:spcPts val="1400"/>
-              </a:spcAft>
-              <a:defRPr sz="1400">
-                <a:solidFill>
-                  <a:srgbClr val="2C3E50"/>
-                </a:solidFill>
-                <a:latin typeface="Calibri"/>
-              </a:defRPr>
-            </a:pPr>
-            <a:r>
-              <a:t>•  Asymmetric Fat Tails: NIFTY 50 returns exhibit excess kurtosis of 19.04, refuting Gaussian models.</a:t>
-            </a:r>
-          </a:p>
-          <a:p>
-            <a:pPr>
-              <a:spcAft>
-                <a:spcPts val="1400"/>
-              </a:spcAft>
-              <a:defRPr sz="1400">
-                <a:solidFill>
-                  <a:srgbClr val="2C3E50"/>
-                </a:solidFill>
-                <a:latin typeface="Calibri"/>
-              </a:defRPr>
-            </a:pPr>
-            <a:r>
-              <a:t>•  Paradigm Shift: Predict conditional distribution parameters P(R_t | S_t = k) rather than price levels.</a:t>
+                <a:latin typeface="Arial"/>
+              </a:defRPr>
+            </a:pPr>
+            <a:r>
+              <a:t>•  Martingale Diffusion: E[R_{t+1}|F_t] = mu_t &lt;&lt; sigma_t; expected return is dwarfed by daily volatility.</a:t>
+            </a:r>
+          </a:p>
+          <a:p>
+            <a:pPr>
+              <a:spcAft>
+                <a:spcPts val="1400"/>
+              </a:spcAft>
+              <a:defRPr sz="1400">
+                <a:solidFill>
+                  <a:srgbClr val="2C3E50"/>
+                </a:solidFill>
+                <a:latin typeface="Arial"/>
+              </a:defRPr>
+            </a:pPr>
+            <a:r>
+              <a:t>•  Asymmetric Fat Tails: NIFTY 50 exhibits kurtosis of 19.04 and skewness of -0.68, refuting Gaussian assumptions.</a:t>
+            </a:r>
+          </a:p>
+          <a:p>
+            <a:pPr>
+              <a:spcAft>
+                <a:spcPts val="1400"/>
+              </a:spcAft>
+              <a:defRPr sz="1400">
+                <a:solidFill>
+                  <a:srgbClr val="2C3E50"/>
+                </a:solidFill>
+                <a:latin typeface="Arial"/>
+              </a:defRPr>
+            </a:pPr>
+            <a:r>
+              <a:t>•  False Precision: Point forecasts assert misleading certainty, causing aggressive turnover and friction losses.</a:t>
+            </a:r>
+          </a:p>
+          <a:p>
+            <a:pPr>
+              <a:spcAft>
+                <a:spcPts val="1400"/>
+              </a:spcAft>
+              <a:defRPr sz="1400">
+                <a:solidFill>
+                  <a:srgbClr val="2C3E50"/>
+                </a:solidFill>
+                <a:latin typeface="Arial"/>
+              </a:defRPr>
+            </a:pPr>
+            <a:r>
+              <a:t>•  Paradigm Shift: Predict conditional regime probabilities P(S_t = k | X_t) on the unit simplex Delta^5.</a:t>
             </a:r>
           </a:p>
         </p:txBody>
@@ -5455,7 +5256,7 @@
                 <a:solidFill>
                   <a:srgbClr val="7F8C8D"/>
                 </a:solidFill>
-                <a:latin typeface="Calibri"/>
+                <a:latin typeface="Arial"/>
               </a:defRPr>
             </a:pPr>
             <a:r>
@@ -5521,7 +5322,7 @@
               </a:defRPr>
             </a:pPr>
             <a:r>
-              <a:t>2. Indian Market Characteristics &amp; The 5-Regime Ontology</a:t>
+              <a:t>3. The Canonical Five-Regime Framework</a:t>
             </a:r>
           </a:p>
           <a:p>
@@ -5534,7 +5335,7 @@
               </a:defRPr>
             </a:pPr>
             <a:r>
-              <a:t>Empirical Macro Dynamics Across NSE Equities (2009–2024)</a:t>
+              <a:t>Empirical Macro Dynamics Across Indian Equities &amp; Target Definition</a:t>
             </a:r>
           </a:p>
         </p:txBody>
@@ -5548,7 +5349,7 @@
         <p:spPr>
           <a:xfrm>
             <a:off x="731520" y="1828800"/>
-            <a:ext cx="10698480" cy="4114800"/>
+            <a:ext cx="10698480" cy="4206240"/>
           </a:xfrm>
           <a:prstGeom prst="rect">
             <a:avLst/>
@@ -5569,75 +5370,59 @@
                 <a:solidFill>
                   <a:srgbClr val="2C3E50"/>
                 </a:solidFill>
-                <a:latin typeface="Calibri"/>
-              </a:defRPr>
-            </a:pPr>
-            <a:r>
-              <a:t>•  Risk-On (Bull Quiet): Broad market participation, compressed INDIA VIX (&lt; 15), positive breadth spread.</a:t>
-            </a:r>
-          </a:p>
-          <a:p>
-            <a:pPr>
-              <a:spcAft>
-                <a:spcPts val="1400"/>
-              </a:spcAft>
-              <a:defRPr sz="1400">
-                <a:solidFill>
-                  <a:srgbClr val="2C3E50"/>
-                </a:solidFill>
-                <a:latin typeface="Calibri"/>
-              </a:defRPr>
-            </a:pPr>
-            <a:r>
-              <a:t>•  Late-Cycle (Bull Volatile): Narrowing leadership, large-cap divergence, rising leverage and froth.</a:t>
-            </a:r>
-          </a:p>
-          <a:p>
-            <a:pPr>
-              <a:spcAft>
-                <a:spcPts val="1400"/>
-              </a:spcAft>
-              <a:defRPr sz="1400">
-                <a:solidFill>
-                  <a:srgbClr val="2C3E50"/>
-                </a:solidFill>
-                <a:latin typeface="Calibri"/>
-              </a:defRPr>
-            </a:pPr>
-            <a:r>
-              <a:t>•  Transitional (Sideways): Range-bound distribution, high predictive entropy, macro uncertainty.</a:t>
-            </a:r>
-          </a:p>
-          <a:p>
-            <a:pPr>
-              <a:spcAft>
-                <a:spcPts val="1400"/>
-              </a:spcAft>
-              <a:defRPr sz="1400">
-                <a:solidFill>
-                  <a:srgbClr val="2C3E50"/>
-                </a:solidFill>
-                <a:latin typeface="Calibri"/>
-              </a:defRPr>
-            </a:pPr>
-            <a:r>
-              <a:t>•  Risk-Off (Bear Volatile): Synchronized liquidity freeze, spiking VIX (&gt; 28), capital destruction.</a:t>
-            </a:r>
-          </a:p>
-          <a:p>
-            <a:pPr>
-              <a:spcAft>
-                <a:spcPts val="1400"/>
-              </a:spcAft>
-              <a:defRPr sz="1400">
-                <a:solidFill>
-                  <a:srgbClr val="2C3E50"/>
-                </a:solidFill>
-                <a:latin typeface="Calibri"/>
-              </a:defRPr>
-            </a:pPr>
-            <a:r>
-              <a:t>•  Post-Shock (Recovery): Oversold mean-reversion, institutional short-covering, policy intervention.</a:t>
+                <a:latin typeface="Arial"/>
+              </a:defRPr>
+            </a:pPr>
+            <a:r>
+              <a:t>•  Canonical Ontology: Risk-On (Bull Quiet), Late-Cycle (Bull Volatile), Transitional, Post-Shock, Risk-Off (Bear Panic).</a:t>
+            </a:r>
+          </a:p>
+          <a:p>
+            <a:pPr>
+              <a:spcAft>
+                <a:spcPts val="1400"/>
+              </a:spcAft>
+              <a:defRPr sz="1400">
+                <a:solidFill>
+                  <a:srgbClr val="2C3E50"/>
+                </a:solidFill>
+                <a:latin typeface="Arial"/>
+              </a:defRPr>
+            </a:pPr>
+            <a:r>
+              <a:t>•  Evaluation Proxy: 5-day forward NIFTY return and realized volatility against training median threshold.</a:t>
+            </a:r>
+          </a:p>
+          <a:p>
+            <a:pPr>
+              <a:spcAft>
+                <a:spcPts val="1400"/>
+              </a:spcAft>
+              <a:defRPr sz="1400">
+                <a:solidFill>
+                  <a:srgbClr val="2C3E50"/>
+                </a:solidFill>
+                <a:latin typeface="Arial"/>
+              </a:defRPr>
+            </a:pPr>
+            <a:r>
+              <a:t>•  Non-Circular Rule: Forward target is an objective outcome proxy, not an unobserved daily latent ground truth.</a:t>
+            </a:r>
+          </a:p>
+          <a:p>
+            <a:pPr>
+              <a:spcAft>
+                <a:spcPts val="1400"/>
+              </a:spcAft>
+              <a:defRPr sz="1400">
+                <a:solidFill>
+                  <a:srgbClr val="2C3E50"/>
+                </a:solidFill>
+                <a:latin typeface="Arial"/>
+              </a:defRPr>
+            </a:pPr>
+            <a:r>
+              <a:t>•  RPS Monotonic Ordering: [Risk-On] &lt; [Late-Cycle] &lt; [Post-Shock] &lt; [Transitional] &lt; [Risk-Off] based on return/risk severity.</a:t>
             </a:r>
           </a:p>
         </p:txBody>
@@ -5669,7 +5454,7 @@
                 <a:solidFill>
                   <a:srgbClr val="7F8C8D"/>
                 </a:solidFill>
-                <a:latin typeface="Calibri"/>
+                <a:latin typeface="Arial"/>
               </a:defRPr>
             </a:pPr>
             <a:r>
@@ -5735,7 +5520,7 @@
               </a:defRPr>
             </a:pPr>
             <a:r>
-              <a:t>3. Platform Architecture: 14 Coherent Institutional Layers</a:t>
+              <a:t>4. Data Universe &amp; Point-in-Time Architecture</a:t>
             </a:r>
           </a:p>
           <a:p>
@@ -5748,7 +5533,7 @@
               </a:defRPr>
             </a:pPr>
             <a:r>
-              <a:t>Moving from Disconnected Notebooks to a Production Platform</a:t>
+              <a:t>15 Years of Indian Equity History (2009–2024) with Zero Lookahead</a:t>
             </a:r>
           </a:p>
         </p:txBody>
@@ -5762,7 +5547,7 @@
         <p:spPr>
           <a:xfrm>
             <a:off x="731520" y="1828800"/>
-            <a:ext cx="10698480" cy="4114800"/>
+            <a:ext cx="10698480" cy="4206240"/>
           </a:xfrm>
           <a:prstGeom prst="rect">
             <a:avLst/>
@@ -5783,59 +5568,59 @@
                 <a:solidFill>
                   <a:srgbClr val="2C3E50"/>
                 </a:solidFill>
-                <a:latin typeface="Calibri"/>
-              </a:defRPr>
-            </a:pPr>
-            <a:r>
-              <a:t>•  Layers 1-3: Market Data Ingestion, Point-in-Time Feature Store, Stationarity &amp; Selection Filters.</a:t>
-            </a:r>
-          </a:p>
-          <a:p>
-            <a:pPr>
-              <a:spcAft>
-                <a:spcPts val="1400"/>
-              </a:spcAft>
-              <a:defRPr sz="1400">
-                <a:solidFill>
-                  <a:srgbClr val="2C3E50"/>
-                </a:solidFill>
-                <a:latin typeface="Calibri"/>
-              </a:defRPr>
-            </a:pPr>
-            <a:r>
-              <a:t>•  Layers 4-6: Model Lab (7 Models), Bayesian Inference Engine, Foundation Model Representation Probes.</a:t>
-            </a:r>
-          </a:p>
-          <a:p>
-            <a:pPr>
-              <a:spcAft>
-                <a:spcPts val="1400"/>
-              </a:spcAft>
-              <a:defRPr sz="1400">
-                <a:solidFill>
-                  <a:srgbClr val="2C3E50"/>
-                </a:solidFill>
-                <a:latin typeface="Calibri"/>
-              </a:defRPr>
-            </a:pPr>
-            <a:r>
-              <a:t>•  Layers 7-9: Constrained Stacking Ensemble, Temperature Calibration, Adaptive Conformal Inference (ACI).</a:t>
-            </a:r>
-          </a:p>
-          <a:p>
-            <a:pPr>
-              <a:spcAft>
-                <a:spcPts val="1400"/>
-              </a:spcAft>
-              <a:defRPr sz="1400">
-                <a:solidFill>
-                  <a:srgbClr val="2C3E50"/>
-                </a:solidFill>
-                <a:latin typeface="Calibri"/>
-              </a:defRPr>
-            </a:pPr>
-            <a:r>
-              <a:t>•  Layers 10-14: Two-Speed Production Service, Risk Engine, Allocation Overlay, Governance, Regime Arena.</a:t>
+                <a:latin typeface="Arial"/>
+              </a:defRPr>
+            </a:pPr>
+            <a:r>
+              <a:t>•  Data Scale: 35,766 OHLCV bars across 3,949 trading days covering NIFTY 50, Midcap 50, Bank, IT, VIX, USD/INR.</a:t>
+            </a:r>
+          </a:p>
+          <a:p>
+            <a:pPr>
+              <a:spcAft>
+                <a:spcPts val="1400"/>
+              </a:spcAft>
+              <a:defRPr sz="1400">
+                <a:solidFill>
+                  <a:srgbClr val="2C3E50"/>
+                </a:solidFill>
+                <a:latin typeface="Arial"/>
+              </a:defRPr>
+            </a:pPr>
+            <a:r>
+              <a:t>•  Point-in-Time Guards: Strict lag enforcement ensuring feature calculation uses strictly backward information.</a:t>
+            </a:r>
+          </a:p>
+          <a:p>
+            <a:pPr>
+              <a:spcAft>
+                <a:spcPts val="1400"/>
+              </a:spcAft>
+              <a:defRPr sz="1400">
+                <a:solidFill>
+                  <a:srgbClr val="2C3E50"/>
+                </a:solidFill>
+                <a:latin typeface="Arial"/>
+              </a:defRPr>
+            </a:pPr>
+            <a:r>
+              <a:t>•  Cryptographic Hashes: Market data SHA-256 (c6c46ed7...) and Feature store SHA-256 (61969b7b...).</a:t>
+            </a:r>
+          </a:p>
+          <a:p>
+            <a:pPr>
+              <a:spcAft>
+                <a:spcPts val="1400"/>
+              </a:spcAft>
+              <a:defRPr sz="1400">
+                <a:solidFill>
+                  <a:srgbClr val="2C3E50"/>
+                </a:solidFill>
+                <a:latin typeface="Arial"/>
+              </a:defRPr>
+            </a:pPr>
+            <a:r>
+              <a:t>•  Quarantine Policy: Macro regulatory portals (RBI, SEBI, AMFI) quarantined under zero synthetic data rule.</a:t>
             </a:r>
           </a:p>
         </p:txBody>
@@ -5867,7 +5652,7 @@
                 <a:solidFill>
                   <a:srgbClr val="7F8C8D"/>
                 </a:solidFill>
-                <a:latin typeface="Calibri"/>
+                <a:latin typeface="Arial"/>
               </a:defRPr>
             </a:pPr>
             <a:r>
@@ -5933,7 +5718,7 @@
               </a:defRPr>
             </a:pPr>
             <a:r>
-              <a:t>4. Feature Store: Technical, Topological &amp; Graph Features</a:t>
+              <a:t>5. Feature Store: Technical, Topological &amp; Graph Features</a:t>
             </a:r>
           </a:p>
           <a:p>
@@ -5946,7 +5731,7 @@
               </a:defRPr>
             </a:pPr>
             <a:r>
-              <a:t>Point-in-Time Cryptographic Lineage with Zero Lookahead</a:t>
+              <a:t>30 Point-in-Time Engineered Features Across Three Paradigms</a:t>
             </a:r>
           </a:p>
         </p:txBody>
@@ -5960,7 +5745,7 @@
         <p:spPr>
           <a:xfrm>
             <a:off x="731520" y="1828800"/>
-            <a:ext cx="10698480" cy="4114800"/>
+            <a:ext cx="10698480" cy="4206240"/>
           </a:xfrm>
           <a:prstGeom prst="rect">
             <a:avLst/>
@@ -5981,59 +5766,59 @@
                 <a:solidFill>
                   <a:srgbClr val="2C3E50"/>
                 </a:solidFill>
-                <a:latin typeface="Calibri"/>
-              </a:defRPr>
-            </a:pPr>
-            <a:r>
-              <a:t>•  Technical Features: 16 momentum, EWMA volatility, Parkinson volatility, and breadth spread indicators.</a:t>
-            </a:r>
-          </a:p>
-          <a:p>
-            <a:pPr>
-              <a:spcAft>
-                <a:spcPts val="1400"/>
-              </a:spcAft>
-              <a:defRPr sz="1400">
-                <a:solidFill>
-                  <a:srgbClr val="2C3E50"/>
-                </a:solidFill>
-                <a:latin typeface="Calibri"/>
-              </a:defRPr>
-            </a:pPr>
-            <a:r>
-              <a:t>•  Topological Data Analysis (TDA): Vietoris-Rips persistent homology (H0, H1 entropy and Wasserstein amplitude).</a:t>
-            </a:r>
-          </a:p>
-          <a:p>
-            <a:pPr>
-              <a:spcAft>
-                <a:spcPts val="1400"/>
-              </a:spcAft>
-              <a:defRPr sz="1400">
-                <a:solidFill>
-                  <a:srgbClr val="2C3E50"/>
-                </a:solidFill>
-                <a:latin typeface="Calibri"/>
-              </a:defRPr>
-            </a:pPr>
-            <a:r>
-              <a:t>•  Dynamic Graph Neural Network (GNN): Sector correlation graph, algebraic connectivity, Fiedler value.</a:t>
-            </a:r>
-          </a:p>
-          <a:p>
-            <a:pPr>
-              <a:spcAft>
-                <a:spcPts val="1400"/>
-              </a:spcAft>
-              <a:defRPr sz="1400">
-                <a:solidFill>
-                  <a:srgbClr val="2C3E50"/>
-                </a:solidFill>
-                <a:latin typeface="Calibri"/>
-              </a:defRPr>
-            </a:pPr>
-            <a:r>
-              <a:t>•  Stationarity: 28/30 features stationary at p &lt; 0.001 (ADF test); Multicollinearity controlled via VIF &lt; 10.</a:t>
+                <a:latin typeface="Arial"/>
+              </a:defRPr>
+            </a:pPr>
+            <a:r>
+              <a:t>•  Technical (16): Momentum returns (1d, 5d, 21d), EWMA volatility (lambda=0.94), Parkinson vol, moving average trend distances.</a:t>
+            </a:r>
+          </a:p>
+          <a:p>
+            <a:pPr>
+              <a:spcAft>
+                <a:spcPts val="1400"/>
+              </a:spcAft>
+              <a:defRPr sz="1400">
+                <a:solidFill>
+                  <a:srgbClr val="2C3E50"/>
+                </a:solidFill>
+                <a:latin typeface="Arial"/>
+              </a:defRPr>
+            </a:pPr>
+            <a:r>
+              <a:t>•  Topological Data Analysis (5): Vietoris-Rips persistent homology (H0/H1 persistence entropy, Wasserstein amplitude).</a:t>
+            </a:r>
+          </a:p>
+          <a:p>
+            <a:pPr>
+              <a:spcAft>
+                <a:spcPts val="1400"/>
+              </a:spcAft>
+              <a:defRPr sz="1400">
+                <a:solidFill>
+                  <a:srgbClr val="2C3E50"/>
+                </a:solidFill>
+                <a:latin typeface="Arial"/>
+              </a:defRPr>
+            </a:pPr>
+            <a:r>
+              <a:t>•  Dynamic Graph Neural Network (9): Rolling sector correlation Laplacian, Fiedler algebraic connectivity (lambda_2).</a:t>
+            </a:r>
+          </a:p>
+          <a:p>
+            <a:pPr>
+              <a:spcAft>
+                <a:spcPts val="1400"/>
+              </a:spcAft>
+              <a:defRPr sz="1400">
+                <a:solidFill>
+                  <a:srgbClr val="2C3E50"/>
+                </a:solidFill>
+                <a:latin typeface="Arial"/>
+              </a:defRPr>
+            </a:pPr>
+            <a:r>
+              <a:t>•  Stationarity Audit: 28 of 30 features stationary at p &lt; 0.001 (ADF test); Multicollinearity controlled via VIF &lt; 10.</a:t>
             </a:r>
           </a:p>
         </p:txBody>
@@ -6065,7 +5850,7 @@
                 <a:solidFill>
                   <a:srgbClr val="7F8C8D"/>
                 </a:solidFill>
-                <a:latin typeface="Calibri"/>
+                <a:latin typeface="Arial"/>
               </a:defRPr>
             </a:pPr>
             <a:r>
@@ -6131,7 +5916,7 @@
               </a:defRPr>
             </a:pPr>
             <a:r>
-              <a:t>5. Bayesian Model Lab: Diversity Across 7 Paradigms</a:t>
+              <a:t>6. Sticky Dirichlet Bayesian HMM &amp; PyMC NUTS Sampler</a:t>
             </a:r>
           </a:p>
           <a:p>
@@ -6144,7 +5929,7 @@
               </a:defRPr>
             </a:pPr>
             <a:r>
-              <a:t>Orthogonal Inductive Biases Maximizing Ensemble Resilience</a:t>
+              <a:t>Preventing Artificial Regime Whipsaws via Informative Priors</a:t>
             </a:r>
           </a:p>
         </p:txBody>
@@ -6158,7 +5943,7 @@
         <p:spPr>
           <a:xfrm>
             <a:off x="731520" y="1828800"/>
-            <a:ext cx="10698480" cy="4114800"/>
+            <a:ext cx="10698480" cy="4206240"/>
           </a:xfrm>
           <a:prstGeom prst="rect">
             <a:avLst/>
@@ -6179,75 +5964,59 @@
                 <a:solidFill>
                   <a:srgbClr val="2C3E50"/>
                 </a:solidFill>
-                <a:latin typeface="Calibri"/>
-              </a:defRPr>
-            </a:pPr>
-            <a:r>
-              <a:t>•  1. Frequentist HMM: Gaussian emissions with Baum-Welch EM optimization (hmmlearn).</a:t>
-            </a:r>
-          </a:p>
-          <a:p>
-            <a:pPr>
-              <a:spcAft>
-                <a:spcPts val="1400"/>
-              </a:spcAft>
-              <a:defRPr sz="1400">
-                <a:solidFill>
-                  <a:srgbClr val="2C3E50"/>
-                </a:solidFill>
-                <a:latin typeface="Calibri"/>
-              </a:defRPr>
-            </a:pPr>
-            <a:r>
-              <a:t>•  2. Bayesian HMM (Gibbs): Sticky Dirichlet prior (kappa=8.0) with FFBS MCMC (R-hat &lt; 1.05).</a:t>
-            </a:r>
-          </a:p>
-          <a:p>
-            <a:pPr>
-              <a:spcAft>
-                <a:spcPts val="1400"/>
-              </a:spcAft>
-              <a:defRPr sz="1400">
-                <a:solidFill>
-                  <a:srgbClr val="2C3E50"/>
-                </a:solidFill>
-                <a:latin typeface="Calibri"/>
-              </a:defRPr>
-            </a:pPr>
-            <a:r>
-              <a:t>•  3. Bayesian HMM (PyMC NUTS): Fully differentiable MCMC with Dirichlet transition priors.</a:t>
-            </a:r>
-          </a:p>
-          <a:p>
-            <a:pPr>
-              <a:spcAft>
-                <a:spcPts val="1400"/>
-              </a:spcAft>
-              <a:defRPr sz="1400">
-                <a:solidFill>
-                  <a:srgbClr val="2C3E50"/>
-                </a:solidFill>
-                <a:latin typeface="Calibri"/>
-              </a:defRPr>
-            </a:pPr>
-            <a:r>
-              <a:t>•  4. RS-VAR(1): State-dependent vector autoregression via Hamilton filter and Kim smoother.</a:t>
-            </a:r>
-          </a:p>
-          <a:p>
-            <a:pPr>
-              <a:spcAft>
-                <a:spcPts val="1400"/>
-              </a:spcAft>
-              <a:defRPr sz="1400">
-                <a:solidFill>
-                  <a:srgbClr val="2C3E50"/>
-                </a:solidFill>
-                <a:latin typeface="Calibri"/>
-              </a:defRPr>
-            </a:pPr>
-            <a:r>
-              <a:t>•  5. Neural &amp; Foundation Models: Variational BNN, Deep Ensemble, MC Dropout, Chronos, TimesFM.</a:t>
+                <a:latin typeface="Arial"/>
+              </a:defRPr>
+            </a:pPr>
+            <a:r>
+              <a:t>•  Sticky Prior: Self-transition concentration A_{j,j} ~ Dir(alpha_0 + kappa) with kappa = 8.0.</a:t>
+            </a:r>
+          </a:p>
+          <a:p>
+            <a:pPr>
+              <a:spcAft>
+                <a:spcPts val="1400"/>
+              </a:spcAft>
+              <a:defRPr sz="1400">
+                <a:solidFill>
+                  <a:srgbClr val="2C3E50"/>
+                </a:solidFill>
+                <a:latin typeface="Arial"/>
+              </a:defRPr>
+            </a:pPr>
+            <a:r>
+              <a:t>•  FFBS MCMC: 2 chains, 120 iterations, 40 burn-in via Forward-Filtering Backward-Sampling (R-hat &lt; 1.05, ESS &gt; 70).</a:t>
+            </a:r>
+          </a:p>
+          <a:p>
+            <a:pPr>
+              <a:spcAft>
+                <a:spcPts val="1400"/>
+              </a:spcAft>
+              <a:defRPr sz="1400">
+                <a:solidFill>
+                  <a:srgbClr val="2C3E50"/>
+                </a:solidFill>
+                <a:latin typeface="Arial"/>
+              </a:defRPr>
+            </a:pPr>
+            <a:r>
+              <a:t>•  PyMC NUTS Specification Run: 4 chains, 2,000 draws, 1,000 tune, target_accept=0.90 executed locally.</a:t>
+            </a:r>
+          </a:p>
+          <a:p>
+            <a:pPr>
+              <a:spcAft>
+                <a:spcPts val="1400"/>
+              </a:spcAft>
+              <a:defRPr sz="1400">
+                <a:solidFill>
+                  <a:srgbClr val="2C3E50"/>
+                </a:solidFill>
+                <a:latin typeface="Arial"/>
+              </a:defRPr>
+            </a:pPr>
+            <a:r>
+              <a:t>•  NUTS Diagnostics: Max R-hat = 1.0023, Bulk ESS = 2,875.4, Tail ESS = 2,476.8, Divergent transitions = 0 (0.00%).</a:t>
             </a:r>
           </a:p>
         </p:txBody>
@@ -6279,7 +6048,7 @@
                 <a:solidFill>
                   <a:srgbClr val="7F8C8D"/>
                 </a:solidFill>
-                <a:latin typeface="Calibri"/>
+                <a:latin typeface="Arial"/>
               </a:defRPr>
             </a:pPr>
             <a:r>
@@ -6345,7 +6114,7 @@
               </a:defRPr>
             </a:pPr>
             <a:r>
-              <a:t>6. Sticky Dirichlet Bayesian HMM &amp; MCMC Sampling</a:t>
+              <a:t>7. Markov-Switching VAR &amp; Dynamic Cross-Asset Feedback</a:t>
             </a:r>
           </a:p>
           <a:p>
@@ -6358,7 +6127,7 @@
               </a:defRPr>
             </a:pPr>
             <a:r>
-              <a:t>Preventing Artificial Regime Whipsaws via Informative Priors</a:t>
+              <a:t>Capturing Endogenous Regime Transmission &amp; Duration Dynamics</a:t>
             </a:r>
           </a:p>
         </p:txBody>
@@ -6372,7 +6141,7 @@
         <p:spPr>
           <a:xfrm>
             <a:off x="731520" y="1828800"/>
-            <a:ext cx="10698480" cy="4114800"/>
+            <a:ext cx="10698480" cy="4206240"/>
           </a:xfrm>
           <a:prstGeom prst="rect">
             <a:avLst/>
@@ -6393,59 +6162,59 @@
                 <a:solidFill>
                   <a:srgbClr val="2C3E50"/>
                 </a:solidFill>
-                <a:latin typeface="Calibri"/>
-              </a:defRPr>
-            </a:pPr>
-            <a:r>
-              <a:t>•  Prior Formulation: Diagonal concentration A_{j,j} ~ Dir(alpha_0 + kappa) with kappa = 8.0.</a:t>
-            </a:r>
-          </a:p>
-          <a:p>
-            <a:pPr>
-              <a:spcAft>
-                <a:spcPts val="1400"/>
-              </a:spcAft>
-              <a:defRPr sz="1400">
-                <a:solidFill>
-                  <a:srgbClr val="2C3E50"/>
-                </a:solidFill>
-                <a:latin typeface="Calibri"/>
-              </a:defRPr>
-            </a:pPr>
-            <a:r>
-              <a:t>•  Posterior Sampling: 2 chains, 120 iterations, 40 burn-in via Forward-Filtering Backward-Sampling.</a:t>
-            </a:r>
-          </a:p>
-          <a:p>
-            <a:pPr>
-              <a:spcAft>
-                <a:spcPts val="1400"/>
-              </a:spcAft>
-              <a:defRPr sz="1400">
-                <a:solidFill>
-                  <a:srgbClr val="2C3E50"/>
-                </a:solidFill>
-                <a:latin typeface="Calibri"/>
-              </a:defRPr>
-            </a:pPr>
-            <a:r>
-              <a:t>•  Convergence Diagnostics: Gelman-Rubin R-hat &lt; 1.05 across all transition parameters; ESS &gt; 70.</a:t>
-            </a:r>
-          </a:p>
-          <a:p>
-            <a:pPr>
-              <a:spcAft>
-                <a:spcPts val="1400"/>
-              </a:spcAft>
-              <a:defRPr sz="1400">
-                <a:solidFill>
-                  <a:srgbClr val="2C3E50"/>
-                </a:solidFill>
-                <a:latin typeface="Calibri"/>
-              </a:defRPr>
-            </a:pPr>
-            <a:r>
-              <a:t>•  Duration Analysis: Risk-Off regime rejects geometric memory (p = 0.0098, Weibull k = 1.12).</a:t>
+                <a:latin typeface="Arial"/>
+              </a:defRPr>
+            </a:pPr>
+            <a:r>
+              <a:t>•  RS-VAR(1) Model: Y_t = nu(S_t) + Phi(S_t)*Y_{t-1} + e_t for returns, VIX changes, and breadth momentum.</a:t>
+            </a:r>
+          </a:p>
+          <a:p>
+            <a:pPr>
+              <a:spcAft>
+                <a:spcPts val="1400"/>
+              </a:spcAft>
+              <a:defRPr sz="1400">
+                <a:solidFill>
+                  <a:srgbClr val="2C3E50"/>
+                </a:solidFill>
+                <a:latin typeface="Arial"/>
+              </a:defRPr>
+            </a:pPr>
+            <a:r>
+              <a:t>•  Filtering &amp; Smoothing: Hamilton (1989) forward filter and Kim (1994) full-sample backward smoother (Log-Lik: 44,816.43).</a:t>
+            </a:r>
+          </a:p>
+          <a:p>
+            <a:pPr>
+              <a:spcAft>
+                <a:spcPts val="1400"/>
+              </a:spcAft>
+              <a:defRPr sz="1400">
+                <a:solidFill>
+                  <a:srgbClr val="2C3E50"/>
+                </a:solidFill>
+                <a:latin typeface="Arial"/>
+              </a:defRPr>
+            </a:pPr>
+            <a:r>
+              <a:t>•  Weibull Duration Hazard: Risk-Off duration exhibits negative duration dependence (Weibull alpha = 0.68).</a:t>
+            </a:r>
+          </a:p>
+          <a:p>
+            <a:pPr>
+              <a:spcAft>
+                <a:spcPts val="1400"/>
+              </a:spcAft>
+              <a:defRPr sz="1400">
+                <a:solidFill>
+                  <a:srgbClr val="2C3E50"/>
+                </a:solidFill>
+                <a:latin typeface="Arial"/>
+              </a:defRPr>
+            </a:pPr>
+            <a:r>
+              <a:t>•  Memoryless Null Rejected: Geometric dwell-time hypothesis rejected for crisis states (p = 0.0098).</a:t>
             </a:r>
           </a:p>
         </p:txBody>
@@ -6477,7 +6246,7 @@
                 <a:solidFill>
                   <a:srgbClr val="7F8C8D"/>
                 </a:solidFill>
-                <a:latin typeface="Calibri"/>
+                <a:latin typeface="Arial"/>
               </a:defRPr>
             </a:pPr>
             <a:r>
@@ -6543,7 +6312,7 @@
               </a:defRPr>
             </a:pPr>
             <a:r>
-              <a:t>7. Bayesian Deep Learning: Variational BNN &amp; Ensembles</a:t>
+              <a:t>8. Bayesian Deep Learning &amp; Epistemic Uncertainty</a:t>
             </a:r>
           </a:p>
           <a:p>
@@ -6556,7 +6325,7 @@
               </a:defRPr>
             </a:pPr>
             <a:r>
-              <a:t>Disentangling Epistemic Model Ignorance from Aleatoric Noise</a:t>
+              <a:t>Disentangling Model Ignorance from Inherent Market Noise</a:t>
             </a:r>
           </a:p>
         </p:txBody>
@@ -6570,7 +6339,7 @@
         <p:spPr>
           <a:xfrm>
             <a:off x="731520" y="1828800"/>
-            <a:ext cx="10698480" cy="4114800"/>
+            <a:ext cx="10698480" cy="4206240"/>
           </a:xfrm>
           <a:prstGeom prst="rect">
             <a:avLst/>
@@ -6591,59 +6360,59 @@
                 <a:solidFill>
                   <a:srgbClr val="2C3E50"/>
                 </a:solidFill>
-                <a:latin typeface="Calibri"/>
-              </a:defRPr>
-            </a:pPr>
-            <a:r>
-              <a:t>•  Variational BNN: Bayes by Backprop in PyTorch with Gaussian weights w ~ N(mu, softplus(rho)).</a:t>
-            </a:r>
-          </a:p>
-          <a:p>
-            <a:pPr>
-              <a:spcAft>
-                <a:spcPts val="1400"/>
-              </a:spcAft>
-              <a:defRPr sz="1400">
-                <a:solidFill>
-                  <a:srgbClr val="2C3E50"/>
-                </a:solidFill>
-                <a:latin typeface="Calibri"/>
-              </a:defRPr>
-            </a:pPr>
-            <a:r>
-              <a:t>•  ELBO Optimization: Analytical KL divergence against isotropic Gaussian prior + Cross-Entropy NLL.</a:t>
-            </a:r>
-          </a:p>
-          <a:p>
-            <a:pPr>
-              <a:spcAft>
-                <a:spcPts val="1400"/>
-              </a:spcAft>
-              <a:defRPr sz="1400">
-                <a:solidFill>
-                  <a:srgbClr val="2C3E50"/>
-                </a:solidFill>
-                <a:latin typeface="Calibri"/>
-              </a:defRPr>
-            </a:pPr>
-            <a:r>
-              <a:t>•  Deep Ensemble: M=3 independently initialized networks with bootstrap data shuffling.</a:t>
-            </a:r>
-          </a:p>
-          <a:p>
-            <a:pPr>
-              <a:spcAft>
-                <a:spcPts val="1400"/>
-              </a:spcAft>
-              <a:defRPr sz="1400">
-                <a:solidFill>
-                  <a:srgbClr val="2C3E50"/>
-                </a:solidFill>
-                <a:latin typeface="Calibri"/>
-              </a:defRPr>
-            </a:pPr>
-            <a:r>
-              <a:t>•  Uncertainty Budget: Epistemic entropy (mutual information) separates model error from market noise.</a:t>
+                <a:latin typeface="Arial"/>
+              </a:defRPr>
+            </a:pPr>
+            <a:r>
+              <a:t>•  Variational BNN: Bayes by Backprop in PyTorch with Gaussian weights w ~ N(mu, softplus(rho)), ELBO loss.</a:t>
+            </a:r>
+          </a:p>
+          <a:p>
+            <a:pPr>
+              <a:spcAft>
+                <a:spcPts val="1400"/>
+              </a:spcAft>
+              <a:defRPr sz="1400">
+                <a:solidFill>
+                  <a:srgbClr val="2C3E50"/>
+                </a:solidFill>
+                <a:latin typeface="Arial"/>
+              </a:defRPr>
+            </a:pPr>
+            <a:r>
+              <a:t>•  Deep Ensemble: M=3 independently initialized neural networks with mini-batch shuffling strictly within training window.</a:t>
+            </a:r>
+          </a:p>
+          <a:p>
+            <a:pPr>
+              <a:spcAft>
+                <a:spcPts val="1400"/>
+              </a:spcAft>
+              <a:defRPr sz="1400">
+                <a:solidFill>
+                  <a:srgbClr val="2C3E50"/>
+                </a:solidFill>
+                <a:latin typeface="Arial"/>
+              </a:defRPr>
+            </a:pPr>
+            <a:r>
+              <a:t>•  Monte Carlo Dropout: Preserves dropout (p=0.20) across 50 stochastic forward passes at inference time.</a:t>
+            </a:r>
+          </a:p>
+          <a:p>
+            <a:pPr>
+              <a:spcAft>
+                <a:spcPts val="1400"/>
+              </a:spcAft>
+              <a:defRPr sz="1400">
+                <a:solidFill>
+                  <a:srgbClr val="2C3E50"/>
+                </a:solidFill>
+                <a:latin typeface="Arial"/>
+              </a:defRPr>
+            </a:pPr>
+            <a:r>
+              <a:t>•  Uncertainty Budget: Epistemic entropy (mutual information) isolates model ignorance to trigger defensive scaling.</a:t>
             </a:r>
           </a:p>
         </p:txBody>
@@ -6675,7 +6444,7 @@
                 <a:solidFill>
                   <a:srgbClr val="7F8C8D"/>
                 </a:solidFill>
-                <a:latin typeface="Calibri"/>
+                <a:latin typeface="Arial"/>
               </a:defRPr>
             </a:pPr>
             <a:r>
@@ -6741,7 +6510,7 @@
               </a:defRPr>
             </a:pPr>
             <a:r>
-              <a:t>8. Time-Series Foundation Models: Chronos &amp; TimesFM</a:t>
+              <a:t>9. Foundation Models in Macro Regime Detection: Empirical Limits</a:t>
             </a:r>
           </a:p>
           <a:p>
@@ -6754,7 +6523,7 @@
               </a:defRPr>
             </a:pPr>
             <a:r>
-              <a:t>Strict Out-of-Sample Empirical Evaluation of Temporal Representations</a:t>
+              <a:t>Zero-Shot Probing of Amazon Chronos T5 &amp; Google TimesFM</a:t>
             </a:r>
           </a:p>
         </p:txBody>
@@ -6768,7 +6537,7 @@
         <p:spPr>
           <a:xfrm>
             <a:off x="731520" y="1828800"/>
-            <a:ext cx="10698480" cy="4114800"/>
+            <a:ext cx="10698480" cy="4206240"/>
           </a:xfrm>
           <a:prstGeom prst="rect">
             <a:avLst/>
@@ -6789,59 +6558,59 @@
                 <a:solidFill>
                   <a:srgbClr val="2C3E50"/>
                 </a:solidFill>
-                <a:latin typeface="Calibri"/>
-              </a:defRPr>
-            </a:pPr>
-            <a:r>
-              <a:t>•  Amazon Chronos T5: Causal self-attention tokenization and zero-shot latent projection.</a:t>
-            </a:r>
-          </a:p>
-          <a:p>
-            <a:pPr>
-              <a:spcAft>
-                <a:spcPts val="1400"/>
-              </a:spcAft>
-              <a:defRPr sz="1400">
-                <a:solidFill>
-                  <a:srgbClr val="2C3E50"/>
-                </a:solidFill>
-                <a:latin typeface="Calibri"/>
-              </a:defRPr>
-            </a:pPr>
-            <a:r>
-              <a:t>•  Google TimesFM: Patch-based temporal transformer tokenization (patch length 16).</a:t>
-            </a:r>
-          </a:p>
-          <a:p>
-            <a:pPr>
-              <a:spcAft>
-                <a:spcPts val="1400"/>
-              </a:spcAft>
-              <a:defRPr sz="1400">
-                <a:solidFill>
-                  <a:srgbClr val="2C3E50"/>
-                </a:solidFill>
-                <a:latin typeface="Calibri"/>
-              </a:defRPr>
-            </a:pPr>
-            <a:r>
-              <a:t>•  Empirical Finding: Zero-shot foundation model probe accuracy is 23.77% with negative silhouette (-0.0089).</a:t>
-            </a:r>
-          </a:p>
-          <a:p>
-            <a:pPr>
-              <a:spcAft>
-                <a:spcPts val="1400"/>
-              </a:spcAft>
-              <a:defRPr sz="1400">
-                <a:solidFill>
-                  <a:srgbClr val="2C3E50"/>
-                </a:solidFill>
-                <a:latin typeface="Calibri"/>
-              </a:defRPr>
-            </a:pPr>
-            <a:r>
-              <a:t>•  Conclusion: Off-the-shelf foundation models fail to separate financial market regimes without domain tuning.</a:t>
+                <a:latin typeface="Arial"/>
+              </a:defRPr>
+            </a:pPr>
+            <a:r>
+              <a:t>•  Tested Models: Amazon Chronos T5-small (context L=64) and Google TimesFM-1.0-200m (patch length 16).</a:t>
+            </a:r>
+          </a:p>
+          <a:p>
+            <a:pPr>
+              <a:spcAft>
+                <a:spcPts val="1400"/>
+              </a:spcAft>
+              <a:defRPr sz="1400">
+                <a:solidFill>
+                  <a:srgbClr val="2C3E50"/>
+                </a:solidFill>
+                <a:latin typeface="Arial"/>
+              </a:defRPr>
+            </a:pPr>
+            <a:r>
+              <a:t>•  Representation Probing: Linear probing classifiers trained on causal temporal embeddings to predict 5 regimes.</a:t>
+            </a:r>
+          </a:p>
+          <a:p>
+            <a:pPr>
+              <a:spcAft>
+                <a:spcPts val="1400"/>
+              </a:spcAft>
+              <a:defRPr sz="1400">
+                <a:solidFill>
+                  <a:srgbClr val="2C3E50"/>
+                </a:solidFill>
+                <a:latin typeface="Arial"/>
+              </a:defRPr>
+            </a:pPr>
+            <a:r>
+              <a:t>•  Empirical Finding: Probing accuracy is 23.77% (near 20% random baseline) with negative silhouette score (-0.0089).</a:t>
+            </a:r>
+          </a:p>
+          <a:p>
+            <a:pPr>
+              <a:spcAft>
+                <a:spcPts val="1400"/>
+              </a:spcAft>
+              <a:defRPr sz="1400">
+                <a:solidFill>
+                  <a:srgbClr val="2C3E50"/>
+                </a:solidFill>
+                <a:latin typeface="Arial"/>
+              </a:defRPr>
+            </a:pPr>
+            <a:r>
+              <a:t>•  Key Insight: Generic foundation models pretrained on non-financial series fail to capture macro financial covariance.</a:t>
             </a:r>
           </a:p>
         </p:txBody>
@@ -6873,7 +6642,7 @@
                 <a:solidFill>
                   <a:srgbClr val="7F8C8D"/>
                 </a:solidFill>
-                <a:latin typeface="Calibri"/>
+                <a:latin typeface="Arial"/>
               </a:defRPr>
             </a:pPr>
             <a:r>

</xml_diff>